<commit_message>
Pitch deck, script, Q&A and short paper refreshed with the slow-table and diagnosis results
Co-Authored-By: Claude Sonnet 5.5 <noreply@anthropic.com>
Claude-Session: https://claude.ai/code/session_014mQCCzGRbma37WnmMzZ7Xo
</commit_message>
<xml_diff>
--- a/docs/SPARK_Cortex_pitch.pptx
+++ b/docs/SPARK_Cortex_pitch.pptx
@@ -18,9 +18,10 @@
     <p:sldId id="266" r:id="rId12"/>
     <p:sldId id="267" r:id="rId13"/>
     <p:sldId id="268" r:id="rId14"/>
+    <p:sldId id="269" r:id="rId15"/>
   </p:sldIdLst>
   <p:notesMasterIdLst>
-    <p:notesMasterId r:id="rId15"/>
+    <p:notesMasterId r:id="rId16"/>
   </p:notesMasterIdLst>
   <p:sldSz cx="9144000" cy="5143500"/>
   <p:notesSz cx="5143500" cy="9144000"/>
@@ -119,41 +120,42 @@
   <p:extLst>
     <p:ext uri="{521415D9-36F7-43E2-AB2F-B90AF26B5E84}">
       <p14:sectionLst xmlns:p14="http://schemas.microsoft.com/office/powerpoint/2010/main">
-        <p14:section name="Open" id="{fc8bd21a-4f31-f3c5-493b-7b676e93a7fa}">
+        <p14:section name="Open" id="{5ff41065-fab5-af45-604a-59f283b2263e}">
           <p14:sldIdLst>
             <p14:sldId id="256"/>
           </p14:sldIdLst>
         </p14:section>
-        <p14:section name="Why" id="{7e0ee36e-18fa-56c7-c8ea-a71ce57d86c7}">
+        <p14:section name="Why" id="{40e805c7-024b-2569-da3b-251581b27d51}">
           <p14:sldIdLst>
             <p14:sldId id="257"/>
             <p14:sldId id="258"/>
           </p14:sldIdLst>
         </p14:section>
-        <p14:section name="Results" id="{27b07526-4699-528a-8eda-e29c696d202a}">
+        <p14:section name="Results" id="{8897a9a4-6e0c-19a1-279b-323592d2c1b0}">
           <p14:sldIdLst>
             <p14:sldId id="259"/>
             <p14:sldId id="260"/>
             <p14:sldId id="261"/>
             <p14:sldId id="262"/>
+            <p14:sldId id="263"/>
           </p14:sldIdLst>
         </p14:section>
-        <p14:section name="Build" id="{60d76cef-0bba-be35-ff12-c698dd791b0a}">
+        <p14:section name="Build" id="{48c7cf29-5af1-513d-8bd6-2ad5fa663df5}">
           <p14:sldIdLst>
-            <p14:sldId id="263"/>
             <p14:sldId id="264"/>
+            <p14:sldId id="265"/>
           </p14:sldIdLst>
         </p14:section>
-        <p14:section name="Honest" id="{56e67936-f334-c4da-d8cc-b362785519a4}">
+        <p14:section name="Honest" id="{51403f78-9ea5-70f4-4793-63572105e827}">
           <p14:sldIdLst>
-            <p14:sldId id="265"/>
             <p14:sldId id="266"/>
+            <p14:sldId id="267"/>
           </p14:sldIdLst>
         </p14:section>
-        <p14:section name="Next" id="{5de23d58-f559-35e9-36a8-ec332573144a}">
+        <p14:section name="Next" id="{9a60aa46-ab06-1710-5722-dc4f66d86d0d}">
           <p14:sldIdLst>
-            <p14:sldId id="267"/>
             <p14:sldId id="268"/>
+            <p14:sldId id="269"/>
           </p14:sldIdLst>
         </p14:section>
       </p14:sectionLst>
@@ -1590,7 +1592,7 @@
                 </a:solidFill>
                 <a:latin typeface="+mn-lt"/>
               </a:rPr>
-              <a:t>Learning everything at once (%)</a:t>
+              <a:t>All at once, chip with LOOK AGAIN (%)</a:t>
             </a:r>
           </a:p>
         </c:rich>
@@ -1614,7 +1616,7 @@
               <c:strCache>
                 <c:ptCount val="1"/>
                 <c:pt idx="0">
-                  <c:v>SPARK Cortex</c:v>
+                  <c:v>SPARK Cortex (slow-table option)</c:v>
                 </c:pt>
               </c:strCache>
             </c:strRef>
@@ -1676,13 +1678,13 @@
                 <c:formatCode>General</c:formatCode>
                 <c:ptCount val="3"/>
                 <c:pt idx="0">
-                  <c:v>98</c:v>
+                  <c:v>98.3</c:v>
                 </c:pt>
                 <c:pt idx="1">
-                  <c:v>84.8</c:v>
+                  <c:v>87.9</c:v>
                 </c:pt>
                 <c:pt idx="2">
-                  <c:v>84.7</c:v>
+                  <c:v>87.2</c:v>
                 </c:pt>
               </c:numCache>
             </c:numRef>
@@ -2421,7 +2423,7 @@
           <a:p>
             <a:r>
               <a:rPr lang="en-US" dirty="0"/>
-              <a:t>This is the slide I want you to remember. All at once, the network is ahead on clothing by two and a half points. Staged clothing is 78 percent; our multi-prototype dreams recover 3 to 4 points but cost two to four times the dream memory. New spoken words from one to five recordings are weak. We tried many fixes and recorded the failures, such as a second sensory layer, wider sound detectors and a shared prototype pool. And nothing is measured on hardware yet.</a:t>
+              <a:t>The design is not just a simulator result. Twenty-one bit-exact checks pass between the integer model and the RTL, covering the core, the few-shot fix, the sense layers, the whole sound chain and the board top. We also took it through an open-source SKY130 layout flow; detailed routing ended at one remaining violation at a memory macro edge. That is an estimate, with no sign-off and no fabrication.</a:t>
             </a:r>
             <a:endParaRPr lang="en-US" dirty="0"/>
           </a:p>
@@ -2509,7 +2511,7 @@
           <a:p>
             <a:r>
               <a:rPr lang="en-US" dirty="0"/>
-              <a:t>We are not the first continual-learning chip. Hyperdimensional-computing accelerators and Intel's Loihi 2 exist. What is new is the combination: dreams generated from small counters so no examples are stored, a night that ends by itself, no multipliers, and a design that is bit-exact from raw senses to the decision. Against hyperdimensional computing in our own test, after five stages we are ahead on digits by 2.2 and on sound by 5.7 points, simulated.</a:t>
+              <a:t>This is the slide I want you to remember. Learning everything at once, with the slow-table option, the chip is level with a small network: 98.3 against 97.8 on digits, 87.9 against 87.3 on clothing, 87.2 against 85.5 on words, simulated, five seeds. Level, not better: a small convolutional network reaches about 89 on clothing and 91 on words. In stages clothing is 78 to 80 percent. New spoken words from one to five recordings are weak. We tried many fixes and recorded the failures, such as a second sensory layer, wider sound detectors and a shared prototype pool. And nothing is measured on hardware yet.</a:t>
             </a:r>
             <a:endParaRPr lang="en-US" dirty="0"/>
           </a:p>
@@ -2597,7 +2599,7 @@
           <a:p>
             <a:r>
               <a:rPr lang="en-US" dirty="0"/>
-              <a:t>What comes next. The model, RTL and layout estimate are done. The next milestone is the real board, which gives the first measured numbers. Then we work on the weak spots, learned word features and higher-fidelity dreams for clothing. The horizon is a provable result within six to eight months, with no fabrication yet.</a:t>
+              <a:t>We are not the first continual-learning chip. Hyperdimensional-computing accelerators and Intel's Loihi 2 exist. What is new is the combination: dreams generated from small counters so no examples are stored, a night that ends by itself, no multipliers, and a design that is bit-exact from raw senses to the decision. Against hyperdimensional computing in our own test, after five stages we are ahead on digits by 2.2 and on sound by 5.7 points, simulated.</a:t>
             </a:r>
             <a:endParaRPr lang="en-US" dirty="0"/>
           </a:p>
@@ -2685,7 +2687,7 @@
           <a:p>
             <a:r>
               <a:rPr lang="en-US" dirty="0"/>
-              <a:t>To close: SPARK Cortex is a chip that keeps learning after it ships. It keeps what it knew, shares what it learned, and needs no multiplier. It is weaker than a network in a few places, and I have told you where. Thank you, I am happy to take questions.</a:t>
+              <a:t>What comes next. The model, RTL and layout estimate are done. The next milestone is the real board, which gives the first measured numbers. Then we work on the weak spots, learned word features and higher-fidelity dreams for clothing. The horizon is a provable result within six to eight months, with no fabrication yet.</a:t>
             </a:r>
             <a:endParaRPr lang="en-US" dirty="0"/>
           </a:p>
@@ -2709,6 +2711,94 @@
             <a:fld id="{F7021451-1387-4CA6-816F-3879F97B5CBC}" type="slidenum">
               <a:rPr lang="en-US"/>
               <a:t>13</a:t>
+            </a:fld>
+            <a:endParaRPr lang="en-US"/>
+          </a:p>
+        </p:txBody>
+      </p:sp>
+    </p:spTree>
+    <p:extLst>
+      <p:ext uri="{BB962C8B-B14F-4D97-AF65-F5344CB8AC3E}">
+        <p14:creationId xmlns:p14="http://schemas.microsoft.com/office/powerpoint/2010/main" val="1024086991"/>
+      </p:ext>
+    </p:extLst>
+  </p:cSld>
+  <p:clrMapOvr>
+    <a:masterClrMapping/>
+  </p:clrMapOvr>
+</p:notes>
+</file>
+
+<file path=ppt/notesSlides/notesSlide14.xml><?xml version="1.0" encoding="utf-8"?>
+<p:notes xmlns:a="http://schemas.openxmlformats.org/drawingml/2006/main" xmlns:r="http://schemas.openxmlformats.org/officeDocument/2006/relationships" xmlns:p="http://schemas.openxmlformats.org/presentationml/2006/main">
+  <p:cSld>
+    <p:spTree>
+      <p:nvGrpSpPr>
+        <p:cNvPr id="1" name=""/>
+        <p:cNvGrpSpPr/>
+        <p:nvPr/>
+      </p:nvGrpSpPr>
+      <p:grpSpPr>
+        <a:xfrm>
+          <a:off x="0" y="0"/>
+          <a:ext cx="0" cy="0"/>
+          <a:chOff x="0" y="0"/>
+          <a:chExt cx="0" cy="0"/>
+        </a:xfrm>
+      </p:grpSpPr>
+      <p:sp>
+        <p:nvSpPr>
+          <p:cNvPr id="2" name="Slide Image Placeholder 1"/>
+          <p:cNvSpPr>
+            <a:spLocks noGrp="1" noRot="1" noChangeAspect="1"/>
+          </p:cNvSpPr>
+          <p:nvPr>
+            <p:ph type="sldImg"/>
+          </p:nvPr>
+        </p:nvSpPr>
+        <p:spPr/>
+      </p:sp>
+      <p:sp>
+        <p:nvSpPr>
+          <p:cNvPr id="3" name="Notes Placeholder 2"/>
+          <p:cNvSpPr>
+            <a:spLocks noGrp="1"/>
+          </p:cNvSpPr>
+          <p:nvPr>
+            <p:ph type="body" idx="1"/>
+          </p:nvPr>
+        </p:nvSpPr>
+        <p:spPr/>
+        <p:txBody>
+          <a:bodyPr/>
+          <a:lstStyle/>
+          <a:p>
+            <a:r>
+              <a:rPr lang="en-US" dirty="0"/>
+              <a:t>To close: SPARK Cortex is a chip that keeps learning after it ships. It keeps what it knew, shares what it learned, and needs no multiplier. It is weaker than a network in a few places, and I have told you where. Thank you, I am happy to take questions.</a:t>
+            </a:r>
+            <a:endParaRPr lang="en-US" dirty="0"/>
+          </a:p>
+        </p:txBody>
+      </p:sp>
+      <p:sp>
+        <p:nvSpPr>
+          <p:cNvPr id="4" name="Slide Number Placeholder 3"/>
+          <p:cNvSpPr>
+            <a:spLocks noGrp="1"/>
+          </p:cNvSpPr>
+          <p:nvPr>
+            <p:ph type="sldNum" sz="quarter" idx="10"/>
+          </p:nvPr>
+        </p:nvSpPr>
+        <p:spPr/>
+        <p:txBody>
+          <a:bodyPr/>
+          <a:lstStyle/>
+          <a:p>
+            <a:fld id="{F7021451-1387-4CA6-816F-3879F97B5CBC}" type="slidenum">
+              <a:rPr lang="en-US"/>
+              <a:t>14</a:t>
             </a:fld>
             <a:endParaRPr lang="en-US"/>
           </a:p>
@@ -3301,7 +3391,7 @@
           <a:p>
             <a:r>
               <a:rPr lang="en-US" dirty="0"/>
-              <a:t>Cost. The image memory is 84 kilobytes. It fits a 25-dollar Tang Nano 20K with no hardware multipliers and timing met. Counting only the operations a decision needs, it uses about 74 times less energy than an 8-bit network, an estimate. I want to be careful: the layout estimate is higher, about a fifth of a microjoule per decision, so the honest wording is 74 times less per operation needed, not per chip.</a:t>
+              <a:t>We asked what actually limits the scores and tested it. A floating-point classifier trained on the chip's own code reaches 87.9 percent on clothing and 98.3 on digits, so the senses are not the limit. The chip's one-pass 5-bit readout is. A slow second table that follows the fast one fixes most of that: clothing 83.4 to 86.9, words 83 to 86, digits 97.0 to 97.6, with shifts and adds only, checked bit-exact in the RTL. A finer detector grid for images adds more, but it makes staged digits worse, so it stays an option. All simulated.</a:t>
             </a:r>
             <a:endParaRPr lang="en-US" dirty="0"/>
           </a:p>
@@ -3389,7 +3479,7 @@
           <a:p>
             <a:r>
               <a:rPr lang="en-US" dirty="0"/>
-              <a:t>The design is not just a simulator result. Eighteen bit-exact checks pass between the integer model and the RTL, covering the core, the few-shot fix, the sense layers, the whole sound chain and the board top. We also took it through an open-source SKY130 layout flow; detailed routing ended at one remaining violation at a memory macro edge. That is an estimate, with no sign-off and no fabrication.</a:t>
+              <a:t>Cost. The image memory is 84 kilobytes. It fits a 25-dollar Tang Nano 20K with no hardware multipliers and timing met. Counting only the operations a decision needs, it uses about 74 times less energy than an 8-bit network, an estimate. I want to be careful: the layout estimate is higher, about a fifth of a microjoule per decision, so the honest wording is 74 times less per operation needed, not per chip.</a:t>
             </a:r>
             <a:endParaRPr lang="en-US" dirty="0"/>
           </a:p>
@@ -4213,38 +4303,49 @@
                 <a:ea typeface="Cambria" pitchFamily="34" charset="-122"/>
                 <a:cs typeface="Cambria" pitchFamily="34" charset="-120"/>
               </a:rPr>
-              <a:t>Where it is weaker, and what we did about it</a:t>
+              <a:t>Verified bit for bit, and laid out</a:t>
             </a:r>
             <a:endParaRPr lang="en-US" sz="3000" dirty="0"/>
           </a:p>
         </p:txBody>
       </p:sp>
-      <p:graphicFrame>
-        <p:nvGraphicFramePr>
-          <p:cNvPr id="3" name="Chart 0" descr=""/>
-          <p:cNvGraphicFramePr/>
-          <p:nvPr/>
-        </p:nvGraphicFramePr>
-        <p:xfrm>
-          <a:off x="457200" y="1188720"/>
-          <a:ext cx="4206240" cy="3474720"/>
-        </p:xfrm>
-        <a:graphic xmlns:a="http://schemas.openxmlformats.org/drawingml/2006/main">
-          <a:graphicData uri="http://schemas.openxmlformats.org/drawingml/2006/chart">
-            <c:chart xmlns:c="http://schemas.openxmlformats.org/drawingml/2006/chart" r:id="rId1"/>
-          </a:graphicData>
-        </a:graphic>
-      </p:graphicFrame>
-      <p:sp>
-        <p:nvSpPr>
-          <p:cNvPr id="4" name="Text 1"/>
+      <p:sp>
+        <p:nvSpPr>
+          <p:cNvPr id="3" name="card"/>
+          <p:cNvSpPr/>
+          <p:nvPr/>
+        </p:nvSpPr>
+        <p:spPr>
+          <a:xfrm>
+            <a:off x="457200" y="1280160"/>
+            <a:ext cx="4023360" cy="3200400"/>
+          </a:xfrm>
+          <a:prstGeom prst="roundRect">
+            <a:avLst>
+              <a:gd name="adj" fmla="val 2857"/>
+            </a:avLst>
+          </a:prstGeom>
+          <a:solidFill>
+            <a:schemeClr val="bg2"/>
+          </a:solidFill>
+          <a:ln w="12700">
+            <a:solidFill>
+              <a:schemeClr val="bg2"/>
+            </a:solidFill>
+            <a:prstDash val="solid"/>
+          </a:ln>
+        </p:spPr>
+      </p:sp>
+      <p:sp>
+        <p:nvSpPr>
+          <p:cNvPr id="4" name="Text 2"/>
           <p:cNvSpPr txBox="1"/>
           <p:nvPr/>
         </p:nvSpPr>
         <p:spPr>
           <a:xfrm>
-            <a:off x="4846320" y="1280160"/>
-            <a:ext cx="3840480" cy="3291840"/>
+            <a:off x="640080" y="1417320"/>
+            <a:ext cx="3657600" cy="914400"/>
           </a:xfrm>
           <a:prstGeom prst="rect">
             <a:avLst/>
@@ -4256,12 +4357,47 @@
           <a:bodyPr wrap="square" lIns="0" tIns="0" rIns="0" bIns="0" rtlCol="0" anchor="t"/>
           <a:lstStyle/>
           <a:p>
-            <a:pPr marL="342900" indent="-342900">
-              <a:spcAft>
-                <a:spcPts val="800"/>
-              </a:spcAft>
-              <a:buSzPct val="100000"/>
-              <a:buChar char="•"/>
+            <a:pPr indent="0" marL="0">
+              <a:buNone/>
+            </a:pPr>
+            <a:r>
+              <a:rPr lang="en-US" sz="5400" b="1" dirty="0">
+                <a:solidFill>
+                  <a:schemeClr val="accent3"/>
+                </a:solidFill>
+                <a:latin typeface="Cambria" pitchFamily="34" charset="0"/>
+                <a:ea typeface="Cambria" pitchFamily="34" charset="-122"/>
+                <a:cs typeface="Cambria" pitchFamily="34" charset="-120"/>
+              </a:rPr>
+              <a:t>21 / 21</a:t>
+            </a:r>
+            <a:endParaRPr lang="en-US" sz="5400" dirty="0"/>
+          </a:p>
+        </p:txBody>
+      </p:sp>
+      <p:sp>
+        <p:nvSpPr>
+          <p:cNvPr id="5" name="Text 3"/>
+          <p:cNvSpPr txBox="1"/>
+          <p:nvPr/>
+        </p:nvSpPr>
+        <p:spPr>
+          <a:xfrm>
+            <a:off x="640080" y="2514600"/>
+            <a:ext cx="3657600" cy="1645920"/>
+          </a:xfrm>
+          <a:prstGeom prst="rect">
+            <a:avLst/>
+          </a:prstGeom>
+          <a:noFill/>
+          <a:ln/>
+        </p:spPr>
+        <p:txBody>
+          <a:bodyPr wrap="square" lIns="0" tIns="0" rIns="0" bIns="0" rtlCol="0" anchor="t"/>
+          <a:lstStyle/>
+          <a:p>
+            <a:pPr indent="0" marL="0">
+              <a:buNone/>
             </a:pPr>
             <a:r>
               <a:rPr lang="en-US" sz="1400" dirty="0">
@@ -4272,38 +4408,140 @@
                 <a:ea typeface="Calibri" pitchFamily="34" charset="-122"/>
                 <a:cs typeface="Calibri" pitchFamily="34" charset="-120"/>
               </a:rPr>
-              <a:t>Clothing: 2.5 points behind the network</a:t>
+              <a:t>RTL checks pass with 0 mismatches against the integer model: core, IMPRINT, slow table, encoder, finer-grid encoder, learning detectors, cochlea, sound chain, board top, host schedule.</a:t>
             </a:r>
             <a:endParaRPr lang="en-US" sz="1400" dirty="0"/>
           </a:p>
-          <a:p>
-            <a:pPr marL="342900" indent="-342900">
-              <a:spcAft>
-                <a:spcPts val="800"/>
-              </a:spcAft>
-              <a:buSzPct val="100000"/>
-              <a:buChar char="•"/>
-            </a:pPr>
-            <a:r>
-              <a:rPr lang="en-US" sz="1400" dirty="0">
-                <a:solidFill>
-                  <a:schemeClr val="tx1"/>
+        </p:txBody>
+      </p:sp>
+      <p:sp>
+        <p:nvSpPr>
+          <p:cNvPr id="6" name="Text 4"/>
+          <p:cNvSpPr txBox="1"/>
+          <p:nvPr/>
+        </p:nvSpPr>
+        <p:spPr>
+          <a:xfrm>
+            <a:off x="640080" y="4069080"/>
+            <a:ext cx="3657600" cy="365760"/>
+          </a:xfrm>
+          <a:prstGeom prst="rect">
+            <a:avLst/>
+          </a:prstGeom>
+          <a:noFill/>
+          <a:ln/>
+        </p:spPr>
+        <p:txBody>
+          <a:bodyPr wrap="square" lIns="0" tIns="0" rIns="0" bIns="0" rtlCol="0" anchor="t"/>
+          <a:lstStyle/>
+          <a:p>
+            <a:pPr indent="0" marL="0">
+              <a:buNone/>
+            </a:pPr>
+            <a:r>
+              <a:rPr lang="en-US" sz="1100" b="1" dirty="0">
+                <a:solidFill>
+                  <a:schemeClr val="accent6"/>
                 </a:solidFill>
                 <a:latin typeface="Calibri" pitchFamily="34" charset="0"/>
                 <a:ea typeface="Calibri" pitchFamily="34" charset="-122"/>
                 <a:cs typeface="Calibri" pitchFamily="34" charset="-120"/>
               </a:rPr>
-              <a:t>Staged clothing 78%; multi-prototype dreams reach 81 to 82 for 2 to 4x dream memory</a:t>
-            </a:r>
-            <a:endParaRPr lang="en-US" sz="1400" dirty="0"/>
-          </a:p>
-          <a:p>
-            <a:pPr marL="342900" indent="-342900">
-              <a:spcAft>
-                <a:spcPts val="800"/>
-              </a:spcAft>
-              <a:buSzPct val="100000"/>
-              <a:buChar char="•"/>
+              <a:t>SIMULATED (RTL simulation)</a:t>
+            </a:r>
+            <a:endParaRPr lang="en-US" sz="1100" dirty="0"/>
+          </a:p>
+        </p:txBody>
+      </p:sp>
+      <p:sp>
+        <p:nvSpPr>
+          <p:cNvPr id="7" name="card"/>
+          <p:cNvSpPr/>
+          <p:nvPr/>
+        </p:nvSpPr>
+        <p:spPr>
+          <a:xfrm>
+            <a:off x="4663440" y="1280160"/>
+            <a:ext cx="4023360" cy="3200400"/>
+          </a:xfrm>
+          <a:prstGeom prst="roundRect">
+            <a:avLst>
+              <a:gd name="adj" fmla="val 2857"/>
+            </a:avLst>
+          </a:prstGeom>
+          <a:solidFill>
+            <a:schemeClr val="bg2"/>
+          </a:solidFill>
+          <a:ln w="12700">
+            <a:solidFill>
+              <a:schemeClr val="bg2"/>
+            </a:solidFill>
+            <a:prstDash val="solid"/>
+          </a:ln>
+        </p:spPr>
+      </p:sp>
+      <p:sp>
+        <p:nvSpPr>
+          <p:cNvPr id="8" name="Text 6"/>
+          <p:cNvSpPr txBox="1"/>
+          <p:nvPr/>
+        </p:nvSpPr>
+        <p:spPr>
+          <a:xfrm>
+            <a:off x="4846320" y="1417320"/>
+            <a:ext cx="3657600" cy="914400"/>
+          </a:xfrm>
+          <a:prstGeom prst="rect">
+            <a:avLst/>
+          </a:prstGeom>
+          <a:noFill/>
+          <a:ln/>
+        </p:spPr>
+        <p:txBody>
+          <a:bodyPr wrap="square" lIns="0" tIns="0" rIns="0" bIns="0" rtlCol="0" anchor="t"/>
+          <a:lstStyle/>
+          <a:p>
+            <a:pPr indent="0" marL="0">
+              <a:buNone/>
+            </a:pPr>
+            <a:r>
+              <a:rPr lang="en-US" sz="5400" b="1" dirty="0">
+                <a:solidFill>
+                  <a:schemeClr val="accent1"/>
+                </a:solidFill>
+                <a:latin typeface="Cambria" pitchFamily="34" charset="0"/>
+                <a:ea typeface="Cambria" pitchFamily="34" charset="-122"/>
+                <a:cs typeface="Cambria" pitchFamily="34" charset="-120"/>
+              </a:rPr>
+              <a:t>1</a:t>
+            </a:r>
+            <a:endParaRPr lang="en-US" sz="5400" dirty="0"/>
+          </a:p>
+        </p:txBody>
+      </p:sp>
+      <p:sp>
+        <p:nvSpPr>
+          <p:cNvPr id="9" name="Text 7"/>
+          <p:cNvSpPr txBox="1"/>
+          <p:nvPr/>
+        </p:nvSpPr>
+        <p:spPr>
+          <a:xfrm>
+            <a:off x="4846320" y="2514600"/>
+            <a:ext cx="3657600" cy="1645920"/>
+          </a:xfrm>
+          <a:prstGeom prst="rect">
+            <a:avLst/>
+          </a:prstGeom>
+          <a:noFill/>
+          <a:ln/>
+        </p:spPr>
+        <p:txBody>
+          <a:bodyPr wrap="square" lIns="0" tIns="0" rIns="0" bIns="0" rtlCol="0" anchor="t"/>
+          <a:lstStyle/>
+          <a:p>
+            <a:pPr indent="0" marL="0">
+              <a:buNone/>
             </a:pPr>
             <a:r>
               <a:rPr lang="en-US" sz="1400" dirty="0">
@@ -4314,30 +4552,48 @@
                 <a:ea typeface="Calibri" pitchFamily="34" charset="-122"/>
                 <a:cs typeface="Calibri" pitchFamily="34" charset="-120"/>
               </a:rPr>
-              <a:t>New spoken words from 1 to 5 recordings: only 12 to 29%</a:t>
+              <a:t>violation left in detailed routing of the SKY130 layout (from 174,309 on the first pass). The last one is a power-versus-signal short at a memory macro edge.</a:t>
             </a:r>
             <a:endParaRPr lang="en-US" sz="1400" dirty="0"/>
           </a:p>
-          <a:p>
-            <a:pPr marL="342900" indent="-342900">
-              <a:spcAft>
-                <a:spcPts val="800"/>
-              </a:spcAft>
-              <a:buSzPct val="100000"/>
-              <a:buChar char="•"/>
-            </a:pPr>
-            <a:r>
-              <a:rPr lang="en-US" sz="1400" dirty="0">
-                <a:solidFill>
-                  <a:schemeClr val="tx1"/>
+        </p:txBody>
+      </p:sp>
+      <p:sp>
+        <p:nvSpPr>
+          <p:cNvPr id="10" name="Text 8"/>
+          <p:cNvSpPr txBox="1"/>
+          <p:nvPr/>
+        </p:nvSpPr>
+        <p:spPr>
+          <a:xfrm>
+            <a:off x="4846320" y="4069080"/>
+            <a:ext cx="3657600" cy="365760"/>
+          </a:xfrm>
+          <a:prstGeom prst="rect">
+            <a:avLst/>
+          </a:prstGeom>
+          <a:noFill/>
+          <a:ln/>
+        </p:spPr>
+        <p:txBody>
+          <a:bodyPr wrap="square" lIns="0" tIns="0" rIns="0" bIns="0" rtlCol="0" anchor="t"/>
+          <a:lstStyle/>
+          <a:p>
+            <a:pPr indent="0" marL="0">
+              <a:buNone/>
+            </a:pPr>
+            <a:r>
+              <a:rPr lang="en-US" sz="1100" b="1" dirty="0">
+                <a:solidFill>
+                  <a:schemeClr val="accent6"/>
                 </a:solidFill>
                 <a:latin typeface="Calibri" pitchFamily="34" charset="0"/>
                 <a:ea typeface="Calibri" pitchFamily="34" charset="-122"/>
                 <a:cs typeface="Calibri" pitchFamily="34" charset="-120"/>
               </a:rPr>
-              <a:t>Nothing measured on hardware yet; board run is next</a:t>
-            </a:r>
-            <a:endParaRPr lang="en-US" sz="1400" dirty="0"/>
+              <a:t>ESTIMATED (open-source flow, no sign-off)</a:t>
+            </a:r>
+            <a:endParaRPr lang="en-US" sz="1100" dirty="0"/>
           </a:p>
         </p:txBody>
       </p:sp>
@@ -4446,115 +4702,38 @@
                 <a:ea typeface="Cambria" pitchFamily="34" charset="-122"/>
                 <a:cs typeface="Cambria" pitchFamily="34" charset="-120"/>
               </a:rPr>
-              <a:t>Not the first, and clear about what is new</a:t>
+              <a:t>Where it is level, and where it is weaker</a:t>
             </a:r>
             <a:endParaRPr lang="en-US" sz="3000" dirty="0"/>
           </a:p>
         </p:txBody>
       </p:sp>
-      <p:sp>
-        <p:nvSpPr>
-          <p:cNvPr id="3" name="card"/>
-          <p:cNvSpPr/>
-          <p:nvPr/>
-        </p:nvSpPr>
-        <p:spPr>
-          <a:xfrm>
-            <a:off x="457200" y="1280160"/>
-            <a:ext cx="4023360" cy="3200400"/>
-          </a:xfrm>
-          <a:prstGeom prst="roundRect">
-            <a:avLst>
-              <a:gd name="adj" fmla="val 2857"/>
-            </a:avLst>
-          </a:prstGeom>
-          <a:solidFill>
-            <a:schemeClr val="bg2"/>
-          </a:solidFill>
-          <a:ln w="12700">
-            <a:solidFill>
-              <a:schemeClr val="bg2"/>
-            </a:solidFill>
-            <a:prstDash val="solid"/>
-          </a:ln>
-        </p:spPr>
-      </p:sp>
-      <p:sp>
-        <p:nvSpPr>
-          <p:cNvPr id="4" name="card"/>
-          <p:cNvSpPr/>
-          <p:nvPr/>
-        </p:nvSpPr>
-        <p:spPr>
-          <a:xfrm>
-            <a:off x="4663440" y="1280160"/>
-            <a:ext cx="4023360" cy="3200400"/>
-          </a:xfrm>
-          <a:prstGeom prst="roundRect">
-            <a:avLst>
-              <a:gd name="adj" fmla="val 2857"/>
-            </a:avLst>
-          </a:prstGeom>
-          <a:solidFill>
-            <a:schemeClr val="bg2"/>
-          </a:solidFill>
-          <a:ln w="12700">
-            <a:solidFill>
-              <a:schemeClr val="bg2"/>
-            </a:solidFill>
-            <a:prstDash val="solid"/>
-          </a:ln>
-        </p:spPr>
-      </p:sp>
-      <p:sp>
-        <p:nvSpPr>
-          <p:cNvPr id="5" name="Text 3"/>
+      <p:graphicFrame>
+        <p:nvGraphicFramePr>
+          <p:cNvPr id="3" name="Chart 0" descr=""/>
+          <p:cNvGraphicFramePr/>
+          <p:nvPr/>
+        </p:nvGraphicFramePr>
+        <p:xfrm>
+          <a:off x="457200" y="1188720"/>
+          <a:ext cx="4206240" cy="3474720"/>
+        </p:xfrm>
+        <a:graphic xmlns:a="http://schemas.openxmlformats.org/drawingml/2006/main">
+          <a:graphicData uri="http://schemas.openxmlformats.org/drawingml/2006/chart">
+            <c:chart xmlns:c="http://schemas.openxmlformats.org/drawingml/2006/chart" r:id="rId1"/>
+          </a:graphicData>
+        </a:graphic>
+      </p:graphicFrame>
+      <p:sp>
+        <p:nvSpPr>
+          <p:cNvPr id="4" name="Text 1"/>
           <p:cNvSpPr txBox="1"/>
           <p:nvPr/>
         </p:nvSpPr>
         <p:spPr>
           <a:xfrm>
-            <a:off x="640080" y="1417320"/>
-            <a:ext cx="3657600" cy="365760"/>
-          </a:xfrm>
-          <a:prstGeom prst="rect">
-            <a:avLst/>
-          </a:prstGeom>
-          <a:noFill/>
-          <a:ln/>
-        </p:spPr>
-        <p:txBody>
-          <a:bodyPr wrap="square" lIns="0" tIns="0" rIns="0" bIns="0" rtlCol="0" anchor="t"/>
-          <a:lstStyle/>
-          <a:p>
-            <a:pPr indent="0" marL="0">
-              <a:buNone/>
-            </a:pPr>
-            <a:r>
-              <a:rPr lang="en-US" sz="2000" b="1" dirty="0">
-                <a:solidFill>
-                  <a:schemeClr val="accent6"/>
-                </a:solidFill>
-                <a:latin typeface="Cambria" pitchFamily="34" charset="0"/>
-                <a:ea typeface="Cambria" pitchFamily="34" charset="-122"/>
-                <a:cs typeface="Cambria" pitchFamily="34" charset="-120"/>
-              </a:rPr>
-              <a:t>Already exists</a:t>
-            </a:r>
-            <a:endParaRPr lang="en-US" sz="2000" dirty="0"/>
-          </a:p>
-        </p:txBody>
-      </p:sp>
-      <p:sp>
-        <p:nvSpPr>
-          <p:cNvPr id="6" name="Text 4"/>
-          <p:cNvSpPr txBox="1"/>
-          <p:nvPr/>
-        </p:nvSpPr>
-        <p:spPr>
-          <a:xfrm>
-            <a:off x="640080" y="1920240"/>
-            <a:ext cx="3657600" cy="2377440"/>
+            <a:off x="4846320" y="1280160"/>
+            <a:ext cx="3840480" cy="3291840"/>
           </a:xfrm>
           <a:prstGeom prst="rect">
             <a:avLst/>
@@ -4568,7 +4747,7 @@
           <a:p>
             <a:pPr marL="342900" indent="-342900">
               <a:spcAft>
-                <a:spcPts val="600"/>
+                <a:spcPts val="800"/>
               </a:spcAft>
               <a:buSzPct val="100000"/>
               <a:buChar char="•"/>
@@ -4582,14 +4761,14 @@
                 <a:ea typeface="Calibri" pitchFamily="34" charset="-122"/>
                 <a:cs typeface="Calibri" pitchFamily="34" charset="-120"/>
               </a:rPr>
-              <a:t>Hyperdimensional-computing accelerators</a:t>
+              <a:t>Level with a small network all at once, not better: a CNN reaches about 89 on clothing and 91 on words</a:t>
             </a:r>
             <a:endParaRPr lang="en-US" sz="1400" dirty="0"/>
           </a:p>
           <a:p>
             <a:pPr marL="342900" indent="-342900">
               <a:spcAft>
-                <a:spcPts val="600"/>
+                <a:spcPts val="800"/>
               </a:spcAft>
               <a:buSzPct val="100000"/>
               <a:buChar char="•"/>
@@ -4603,12 +4782,15 @@
                 <a:ea typeface="Calibri" pitchFamily="34" charset="-122"/>
                 <a:cs typeface="Calibri" pitchFamily="34" charset="-120"/>
               </a:rPr>
-              <a:t>Intel Loihi 2 (continual learning on spiking cores)</a:t>
+              <a:t>In stages clothing is 78 to 80%; digits 95%</a:t>
             </a:r>
             <a:endParaRPr lang="en-US" sz="1400" dirty="0"/>
           </a:p>
           <a:p>
             <a:pPr marL="342900" indent="-342900">
+              <a:spcAft>
+                <a:spcPts val="800"/>
+              </a:spcAft>
               <a:buSzPct val="100000"/>
               <a:buChar char="•"/>
             </a:pPr>
@@ -4621,75 +4803,14 @@
                 <a:ea typeface="Calibri" pitchFamily="34" charset="-122"/>
                 <a:cs typeface="Calibri" pitchFamily="34" charset="-120"/>
               </a:rPr>
-              <a:t>Replay-based continual learning</a:t>
+              <a:t>New spoken words from 1 to 5 recordings: only 12 to 29%</a:t>
             </a:r>
             <a:endParaRPr lang="en-US" sz="1400" dirty="0"/>
           </a:p>
-        </p:txBody>
-      </p:sp>
-      <p:sp>
-        <p:nvSpPr>
-          <p:cNvPr id="7" name="Text 5"/>
-          <p:cNvSpPr txBox="1"/>
-          <p:nvPr/>
-        </p:nvSpPr>
-        <p:spPr>
-          <a:xfrm>
-            <a:off x="4846320" y="1417320"/>
-            <a:ext cx="3657600" cy="365760"/>
-          </a:xfrm>
-          <a:prstGeom prst="rect">
-            <a:avLst/>
-          </a:prstGeom>
-          <a:noFill/>
-          <a:ln/>
-        </p:spPr>
-        <p:txBody>
-          <a:bodyPr wrap="square" lIns="0" tIns="0" rIns="0" bIns="0" rtlCol="0" anchor="t"/>
-          <a:lstStyle/>
-          <a:p>
-            <a:pPr indent="0" marL="0">
-              <a:buNone/>
-            </a:pPr>
-            <a:r>
-              <a:rPr lang="en-US" sz="2000" b="1" dirty="0">
-                <a:solidFill>
-                  <a:schemeClr val="accent2"/>
-                </a:solidFill>
-                <a:latin typeface="Cambria" pitchFamily="34" charset="0"/>
-                <a:ea typeface="Cambria" pitchFamily="34" charset="-122"/>
-                <a:cs typeface="Cambria" pitchFamily="34" charset="-120"/>
-              </a:rPr>
-              <a:t>What we add</a:t>
-            </a:r>
-            <a:endParaRPr lang="en-US" sz="2000" dirty="0"/>
-          </a:p>
-        </p:txBody>
-      </p:sp>
-      <p:sp>
-        <p:nvSpPr>
-          <p:cNvPr id="8" name="Text 6"/>
-          <p:cNvSpPr txBox="1"/>
-          <p:nvPr/>
-        </p:nvSpPr>
-        <p:spPr>
-          <a:xfrm>
-            <a:off x="4846320" y="1920240"/>
-            <a:ext cx="3657600" cy="2468880"/>
-          </a:xfrm>
-          <a:prstGeom prst="rect">
-            <a:avLst/>
-          </a:prstGeom>
-          <a:noFill/>
-          <a:ln/>
-        </p:spPr>
-        <p:txBody>
-          <a:bodyPr wrap="square" lIns="0" tIns="0" rIns="0" bIns="0" rtlCol="0" anchor="t"/>
-          <a:lstStyle/>
           <a:p>
             <a:pPr marL="342900" indent="-342900">
               <a:spcAft>
-                <a:spcPts val="600"/>
+                <a:spcPts val="800"/>
               </a:spcAft>
               <a:buSzPct val="100000"/>
               <a:buChar char="•"/>
@@ -4703,67 +4824,7 @@
                 <a:ea typeface="Calibri" pitchFamily="34" charset="-122"/>
                 <a:cs typeface="Calibri" pitchFamily="34" charset="-120"/>
               </a:rPr>
-              <a:t>Dreams generated from 10-bit counters, no stored examples</a:t>
-            </a:r>
-            <a:endParaRPr lang="en-US" sz="1400" dirty="0"/>
-          </a:p>
-          <a:p>
-            <a:pPr marL="342900" indent="-342900">
-              <a:spcAft>
-                <a:spcPts val="600"/>
-              </a:spcAft>
-              <a:buSzPct val="100000"/>
-              <a:buChar char="•"/>
-            </a:pPr>
-            <a:r>
-              <a:rPr lang="en-US" sz="1400" dirty="0">
-                <a:solidFill>
-                  <a:schemeClr val="tx1"/>
-                </a:solidFill>
-                <a:latin typeface="Calibri" pitchFamily="34" charset="0"/>
-                <a:ea typeface="Calibri" pitchFamily="34" charset="-122"/>
-                <a:cs typeface="Calibri" pitchFamily="34" charset="-120"/>
-              </a:rPr>
-              <a:t>A night that ends by itself</a:t>
-            </a:r>
-            <a:endParaRPr lang="en-US" sz="1400" dirty="0"/>
-          </a:p>
-          <a:p>
-            <a:pPr marL="342900" indent="-342900">
-              <a:spcAft>
-                <a:spcPts val="600"/>
-              </a:spcAft>
-              <a:buSzPct val="100000"/>
-              <a:buChar char="•"/>
-            </a:pPr>
-            <a:r>
-              <a:rPr lang="en-US" sz="1400" dirty="0">
-                <a:solidFill>
-                  <a:schemeClr val="tx1"/>
-                </a:solidFill>
-                <a:latin typeface="Calibri" pitchFamily="34" charset="0"/>
-                <a:ea typeface="Calibri" pitchFamily="34" charset="-122"/>
-                <a:cs typeface="Calibri" pitchFamily="34" charset="-120"/>
-              </a:rPr>
-              <a:t>No multiplier, bit-exact from raw senses to decision</a:t>
-            </a:r>
-            <a:endParaRPr lang="en-US" sz="1400" dirty="0"/>
-          </a:p>
-          <a:p>
-            <a:pPr marL="342900" indent="-342900">
-              <a:buSzPct val="100000"/>
-              <a:buChar char="•"/>
-            </a:pPr>
-            <a:r>
-              <a:rPr lang="en-US" sz="1400" dirty="0">
-                <a:solidFill>
-                  <a:schemeClr val="tx1"/>
-                </a:solidFill>
-                <a:latin typeface="Calibri" pitchFamily="34" charset="0"/>
-                <a:ea typeface="Calibri" pitchFamily="34" charset="-122"/>
-                <a:cs typeface="Calibri" pitchFamily="34" charset="-120"/>
-              </a:rPr>
-              <a:t>Ahead of HDC in our test after 5 stages: digits +2.2, sound +5.7</a:t>
+              <a:t>Nothing measured on hardware yet; board run is next</a:t>
             </a:r>
             <a:endParaRPr lang="en-US" sz="1400" dirty="0"/>
           </a:p>
@@ -4874,7 +4935,7 @@
                 <a:ea typeface="Cambria" pitchFamily="34" charset="-122"/>
                 <a:cs typeface="Cambria" pitchFamily="34" charset="-120"/>
               </a:rPr>
-              <a:t>What comes next</a:t>
+              <a:t>Not the first, and clear about what is new</a:t>
             </a:r>
             <a:endParaRPr lang="en-US" sz="3000" dirty="0"/>
           </a:p>
@@ -4888,12 +4949,12 @@
         </p:nvSpPr>
         <p:spPr>
           <a:xfrm>
-            <a:off x="457200" y="1371600"/>
-            <a:ext cx="1965960" cy="2651760"/>
+            <a:off x="457200" y="1280160"/>
+            <a:ext cx="4023360" cy="3200400"/>
           </a:xfrm>
           <a:prstGeom prst="roundRect">
             <a:avLst>
-              <a:gd name="adj" fmla="val 4651"/>
+              <a:gd name="adj" fmla="val 2857"/>
             </a:avLst>
           </a:prstGeom>
           <a:solidFill>
@@ -4909,160 +4970,18 @@
       </p:sp>
       <p:sp>
         <p:nvSpPr>
-          <p:cNvPr id="4" name="marker"/>
+          <p:cNvPr id="4" name="card"/>
           <p:cNvSpPr/>
           <p:nvPr/>
         </p:nvSpPr>
         <p:spPr>
           <a:xfrm>
-            <a:off x="594360" y="1508760"/>
-            <a:ext cx="502920" cy="502920"/>
-          </a:xfrm>
-          <a:prstGeom prst="ellipse">
-            <a:avLst/>
-          </a:prstGeom>
-          <a:solidFill>
-            <a:schemeClr val="accent3"/>
-          </a:solidFill>
-          <a:ln w="12700">
-            <a:solidFill>
-              <a:schemeClr val="accent3"/>
-            </a:solidFill>
-            <a:prstDash val="solid"/>
-          </a:ln>
-        </p:spPr>
-      </p:sp>
-      <p:sp>
-        <p:nvSpPr>
-          <p:cNvPr id="5" name="Text 3"/>
-          <p:cNvSpPr txBox="1"/>
-          <p:nvPr/>
-        </p:nvSpPr>
-        <p:spPr>
-          <a:xfrm>
-            <a:off x="594360" y="1600200"/>
-            <a:ext cx="502920" cy="365760"/>
-          </a:xfrm>
-          <a:prstGeom prst="rect">
-            <a:avLst/>
-          </a:prstGeom>
-          <a:noFill/>
-          <a:ln/>
-        </p:spPr>
-        <p:txBody>
-          <a:bodyPr wrap="square" lIns="0" tIns="0" rIns="0" bIns="0" rtlCol="0" anchor="t"/>
-          <a:lstStyle/>
-          <a:p>
-            <a:pPr algn="ctr" indent="0" marL="0">
-              <a:buNone/>
-            </a:pPr>
-            <a:r>
-              <a:rPr lang="en-US" sz="1800" b="1" dirty="0">
-                <a:solidFill>
-                  <a:schemeClr val="tx1"/>
-                </a:solidFill>
-                <a:latin typeface="Calibri" pitchFamily="34" charset="0"/>
-                <a:ea typeface="Calibri" pitchFamily="34" charset="-122"/>
-                <a:cs typeface="Calibri" pitchFamily="34" charset="-120"/>
-              </a:rPr>
-              <a:t>1</a:t>
-            </a:r>
-            <a:endParaRPr lang="en-US" sz="1800" dirty="0"/>
-          </a:p>
-        </p:txBody>
-      </p:sp>
-      <p:sp>
-        <p:nvSpPr>
-          <p:cNvPr id="6" name="Text 4"/>
-          <p:cNvSpPr txBox="1"/>
-          <p:nvPr/>
-        </p:nvSpPr>
-        <p:spPr>
-          <a:xfrm>
-            <a:off x="594360" y="2148840"/>
-            <a:ext cx="1691640" cy="365760"/>
-          </a:xfrm>
-          <a:prstGeom prst="rect">
-            <a:avLst/>
-          </a:prstGeom>
-          <a:noFill/>
-          <a:ln/>
-        </p:spPr>
-        <p:txBody>
-          <a:bodyPr wrap="square" lIns="0" tIns="0" rIns="0" bIns="0" rtlCol="0" anchor="t"/>
-          <a:lstStyle/>
-          <a:p>
-            <a:pPr indent="0" marL="0">
-              <a:buNone/>
-            </a:pPr>
-            <a:r>
-              <a:rPr lang="en-US" sz="2000" b="1" dirty="0">
-                <a:solidFill>
-                  <a:schemeClr val="tx1"/>
-                </a:solidFill>
-                <a:latin typeface="Cambria" pitchFamily="34" charset="0"/>
-                <a:ea typeface="Cambria" pitchFamily="34" charset="-122"/>
-                <a:cs typeface="Cambria" pitchFamily="34" charset="-120"/>
-              </a:rPr>
-              <a:t>Done</a:t>
-            </a:r>
-            <a:endParaRPr lang="en-US" sz="2000" dirty="0"/>
-          </a:p>
-        </p:txBody>
-      </p:sp>
-      <p:sp>
-        <p:nvSpPr>
-          <p:cNvPr id="7" name="Text 5"/>
-          <p:cNvSpPr txBox="1"/>
-          <p:nvPr/>
-        </p:nvSpPr>
-        <p:spPr>
-          <a:xfrm>
-            <a:off x="594360" y="2606040"/>
-            <a:ext cx="1691640" cy="1371600"/>
-          </a:xfrm>
-          <a:prstGeom prst="rect">
-            <a:avLst/>
-          </a:prstGeom>
-          <a:noFill/>
-          <a:ln/>
-        </p:spPr>
-        <p:txBody>
-          <a:bodyPr wrap="square" lIns="0" tIns="0" rIns="0" bIns="0" rtlCol="0" anchor="t"/>
-          <a:lstStyle/>
-          <a:p>
-            <a:pPr indent="0" marL="0">
-              <a:buNone/>
-            </a:pPr>
-            <a:r>
-              <a:rPr lang="en-US" sz="1300" dirty="0">
-                <a:solidFill>
-                  <a:schemeClr val="tx1"/>
-                </a:solidFill>
-                <a:latin typeface="Calibri" pitchFamily="34" charset="0"/>
-                <a:ea typeface="Calibri" pitchFamily="34" charset="-122"/>
-                <a:cs typeface="Calibri" pitchFamily="34" charset="-120"/>
-              </a:rPr>
-              <a:t>Model, RTL, 18 checks, FPGA fit, SKY130 layout estimate</a:t>
-            </a:r>
-            <a:endParaRPr lang="en-US" sz="1300" dirty="0"/>
-          </a:p>
-        </p:txBody>
-      </p:sp>
-      <p:sp>
-        <p:nvSpPr>
-          <p:cNvPr id="8" name="card"/>
-          <p:cNvSpPr/>
-          <p:nvPr/>
-        </p:nvSpPr>
-        <p:spPr>
-          <a:xfrm>
-            <a:off x="2560320" y="1371600"/>
-            <a:ext cx="1965960" cy="2651760"/>
+            <a:off x="4663440" y="1280160"/>
+            <a:ext cx="4023360" cy="3200400"/>
           </a:xfrm>
           <a:prstGeom prst="roundRect">
             <a:avLst>
-              <a:gd name="adj" fmla="val 4651"/>
+              <a:gd name="adj" fmla="val 2857"/>
             </a:avLst>
           </a:prstGeom>
           <a:solidFill>
@@ -5078,39 +4997,14 @@
       </p:sp>
       <p:sp>
         <p:nvSpPr>
-          <p:cNvPr id="9" name="marker"/>
-          <p:cNvSpPr/>
-          <p:nvPr/>
-        </p:nvSpPr>
-        <p:spPr>
-          <a:xfrm>
-            <a:off x="2697480" y="1508760"/>
-            <a:ext cx="502920" cy="502920"/>
-          </a:xfrm>
-          <a:prstGeom prst="ellipse">
-            <a:avLst/>
-          </a:prstGeom>
-          <a:solidFill>
-            <a:schemeClr val="accent1"/>
-          </a:solidFill>
-          <a:ln w="12700">
-            <a:solidFill>
-              <a:schemeClr val="accent1"/>
-            </a:solidFill>
-            <a:prstDash val="solid"/>
-          </a:ln>
-        </p:spPr>
-      </p:sp>
-      <p:sp>
-        <p:nvSpPr>
-          <p:cNvPr id="10" name="Text 8"/>
+          <p:cNvPr id="5" name="Text 3"/>
           <p:cNvSpPr txBox="1"/>
           <p:nvPr/>
         </p:nvSpPr>
         <p:spPr>
           <a:xfrm>
-            <a:off x="2697480" y="1600200"/>
-            <a:ext cx="502920" cy="365760"/>
+            <a:off x="640080" y="1417320"/>
+            <a:ext cx="3657600" cy="365760"/>
           </a:xfrm>
           <a:prstGeom prst="rect">
             <a:avLst/>
@@ -5122,11 +5016,54 @@
           <a:bodyPr wrap="square" lIns="0" tIns="0" rIns="0" bIns="0" rtlCol="0" anchor="t"/>
           <a:lstStyle/>
           <a:p>
-            <a:pPr algn="ctr" indent="0" marL="0">
+            <a:pPr indent="0" marL="0">
               <a:buNone/>
             </a:pPr>
             <a:r>
-              <a:rPr lang="en-US" sz="1800" b="1" dirty="0">
+              <a:rPr lang="en-US" sz="2000" b="1" dirty="0">
+                <a:solidFill>
+                  <a:schemeClr val="accent6"/>
+                </a:solidFill>
+                <a:latin typeface="Cambria" pitchFamily="34" charset="0"/>
+                <a:ea typeface="Cambria" pitchFamily="34" charset="-122"/>
+                <a:cs typeface="Cambria" pitchFamily="34" charset="-120"/>
+              </a:rPr>
+              <a:t>Already exists</a:t>
+            </a:r>
+            <a:endParaRPr lang="en-US" sz="2000" dirty="0"/>
+          </a:p>
+        </p:txBody>
+      </p:sp>
+      <p:sp>
+        <p:nvSpPr>
+          <p:cNvPr id="6" name="Text 4"/>
+          <p:cNvSpPr txBox="1"/>
+          <p:nvPr/>
+        </p:nvSpPr>
+        <p:spPr>
+          <a:xfrm>
+            <a:off x="640080" y="1920240"/>
+            <a:ext cx="3657600" cy="2377440"/>
+          </a:xfrm>
+          <a:prstGeom prst="rect">
+            <a:avLst/>
+          </a:prstGeom>
+          <a:noFill/>
+          <a:ln/>
+        </p:spPr>
+        <p:txBody>
+          <a:bodyPr wrap="square" lIns="0" tIns="0" rIns="0" bIns="0" rtlCol="0" anchor="t"/>
+          <a:lstStyle/>
+          <a:p>
+            <a:pPr marL="342900" indent="-342900">
+              <a:spcAft>
+                <a:spcPts val="600"/>
+              </a:spcAft>
+              <a:buSzPct val="100000"/>
+              <a:buChar char="•"/>
+            </a:pPr>
+            <a:r>
+              <a:rPr lang="en-US" sz="1400" dirty="0">
                 <a:solidFill>
                   <a:schemeClr val="tx1"/>
                 </a:solidFill>
@@ -5134,22 +5071,61 @@
                 <a:ea typeface="Calibri" pitchFamily="34" charset="-122"/>
                 <a:cs typeface="Calibri" pitchFamily="34" charset="-120"/>
               </a:rPr>
-              <a:t>2</a:t>
-            </a:r>
-            <a:endParaRPr lang="en-US" sz="1800" dirty="0"/>
-          </a:p>
-        </p:txBody>
-      </p:sp>
-      <p:sp>
-        <p:nvSpPr>
-          <p:cNvPr id="11" name="Text 9"/>
+              <a:t>Hyperdimensional-computing accelerators</a:t>
+            </a:r>
+            <a:endParaRPr lang="en-US" sz="1400" dirty="0"/>
+          </a:p>
+          <a:p>
+            <a:pPr marL="342900" indent="-342900">
+              <a:spcAft>
+                <a:spcPts val="600"/>
+              </a:spcAft>
+              <a:buSzPct val="100000"/>
+              <a:buChar char="•"/>
+            </a:pPr>
+            <a:r>
+              <a:rPr lang="en-US" sz="1400" dirty="0">
+                <a:solidFill>
+                  <a:schemeClr val="tx1"/>
+                </a:solidFill>
+                <a:latin typeface="Calibri" pitchFamily="34" charset="0"/>
+                <a:ea typeface="Calibri" pitchFamily="34" charset="-122"/>
+                <a:cs typeface="Calibri" pitchFamily="34" charset="-120"/>
+              </a:rPr>
+              <a:t>Intel Loihi 2 (continual learning on spiking cores)</a:t>
+            </a:r>
+            <a:endParaRPr lang="en-US" sz="1400" dirty="0"/>
+          </a:p>
+          <a:p>
+            <a:pPr marL="342900" indent="-342900">
+              <a:buSzPct val="100000"/>
+              <a:buChar char="•"/>
+            </a:pPr>
+            <a:r>
+              <a:rPr lang="en-US" sz="1400" dirty="0">
+                <a:solidFill>
+                  <a:schemeClr val="tx1"/>
+                </a:solidFill>
+                <a:latin typeface="Calibri" pitchFamily="34" charset="0"/>
+                <a:ea typeface="Calibri" pitchFamily="34" charset="-122"/>
+                <a:cs typeface="Calibri" pitchFamily="34" charset="-120"/>
+              </a:rPr>
+              <a:t>Replay-based continual learning</a:t>
+            </a:r>
+            <a:endParaRPr lang="en-US" sz="1400" dirty="0"/>
+          </a:p>
+        </p:txBody>
+      </p:sp>
+      <p:sp>
+        <p:nvSpPr>
+          <p:cNvPr id="7" name="Text 5"/>
           <p:cNvSpPr txBox="1"/>
           <p:nvPr/>
         </p:nvSpPr>
         <p:spPr>
           <a:xfrm>
-            <a:off x="2697480" y="2148840"/>
-            <a:ext cx="1691640" cy="365760"/>
+            <a:off x="4846320" y="1417320"/>
+            <a:ext cx="3657600" cy="365760"/>
           </a:xfrm>
           <a:prstGeom prst="rect">
             <a:avLst/>
@@ -5167,13 +5143,13 @@
             <a:r>
               <a:rPr lang="en-US" sz="2000" b="1" dirty="0">
                 <a:solidFill>
-                  <a:schemeClr val="tx1"/>
+                  <a:schemeClr val="accent2"/>
                 </a:solidFill>
                 <a:latin typeface="Cambria" pitchFamily="34" charset="0"/>
                 <a:ea typeface="Cambria" pitchFamily="34" charset="-122"/>
                 <a:cs typeface="Cambria" pitchFamily="34" charset="-120"/>
               </a:rPr>
-              <a:t>Next</a:t>
+              <a:t>What we add</a:t>
             </a:r>
             <a:endParaRPr lang="en-US" sz="2000" dirty="0"/>
           </a:p>
@@ -5181,14 +5157,14 @@
       </p:sp>
       <p:sp>
         <p:nvSpPr>
-          <p:cNvPr id="12" name="Text 10"/>
+          <p:cNvPr id="8" name="Text 6"/>
           <p:cNvSpPr txBox="1"/>
           <p:nvPr/>
         </p:nvSpPr>
         <p:spPr>
           <a:xfrm>
-            <a:off x="2697480" y="2606040"/>
-            <a:ext cx="1691640" cy="1371600"/>
+            <a:off x="4846320" y="1920240"/>
+            <a:ext cx="3657600" cy="2468880"/>
           </a:xfrm>
           <a:prstGeom prst="rect">
             <a:avLst/>
@@ -5200,11 +5176,15 @@
           <a:bodyPr wrap="square" lIns="0" tIns="0" rIns="0" bIns="0" rtlCol="0" anchor="t"/>
           <a:lstStyle/>
           <a:p>
-            <a:pPr indent="0" marL="0">
-              <a:buNone/>
-            </a:pPr>
-            <a:r>
-              <a:rPr lang="en-US" sz="1300" dirty="0">
+            <a:pPr marL="342900" indent="-342900">
+              <a:spcAft>
+                <a:spcPts val="600"/>
+              </a:spcAft>
+              <a:buSzPct val="100000"/>
+              <a:buChar char="•"/>
+            </a:pPr>
+            <a:r>
+              <a:rPr lang="en-US" sz="1400" dirty="0">
                 <a:solidFill>
                   <a:schemeClr val="tx1"/>
                 </a:solidFill>
@@ -5212,90 +5192,20 @@
                 <a:ea typeface="Calibri" pitchFamily="34" charset="-122"/>
                 <a:cs typeface="Calibri" pitchFamily="34" charset="-120"/>
               </a:rPr>
-              <a:t>First run on the real Tang Nano: the first MEASURED numbers</a:t>
-            </a:r>
-            <a:endParaRPr lang="en-US" sz="1300" dirty="0"/>
-          </a:p>
-        </p:txBody>
-      </p:sp>
-      <p:sp>
-        <p:nvSpPr>
-          <p:cNvPr id="13" name="card"/>
-          <p:cNvSpPr/>
-          <p:nvPr/>
-        </p:nvSpPr>
-        <p:spPr>
-          <a:xfrm>
-            <a:off x="4663440" y="1371600"/>
-            <a:ext cx="1965960" cy="2651760"/>
-          </a:xfrm>
-          <a:prstGeom prst="roundRect">
-            <a:avLst>
-              <a:gd name="adj" fmla="val 4651"/>
-            </a:avLst>
-          </a:prstGeom>
-          <a:solidFill>
-            <a:schemeClr val="bg2"/>
-          </a:solidFill>
-          <a:ln w="12700">
-            <a:solidFill>
-              <a:schemeClr val="bg2"/>
-            </a:solidFill>
-            <a:prstDash val="solid"/>
-          </a:ln>
-        </p:spPr>
-      </p:sp>
-      <p:sp>
-        <p:nvSpPr>
-          <p:cNvPr id="14" name="marker"/>
-          <p:cNvSpPr/>
-          <p:nvPr/>
-        </p:nvSpPr>
-        <p:spPr>
-          <a:xfrm>
-            <a:off x="4800600" y="1508760"/>
-            <a:ext cx="502920" cy="502920"/>
-          </a:xfrm>
-          <a:prstGeom prst="ellipse">
-            <a:avLst/>
-          </a:prstGeom>
-          <a:solidFill>
-            <a:schemeClr val="accent2"/>
-          </a:solidFill>
-          <a:ln w="12700">
-            <a:solidFill>
-              <a:schemeClr val="accent2"/>
-            </a:solidFill>
-            <a:prstDash val="solid"/>
-          </a:ln>
-        </p:spPr>
-      </p:sp>
-      <p:sp>
-        <p:nvSpPr>
-          <p:cNvPr id="15" name="Text 13"/>
-          <p:cNvSpPr txBox="1"/>
-          <p:nvPr/>
-        </p:nvSpPr>
-        <p:spPr>
-          <a:xfrm>
-            <a:off x="4800600" y="1600200"/>
-            <a:ext cx="502920" cy="365760"/>
-          </a:xfrm>
-          <a:prstGeom prst="rect">
-            <a:avLst/>
-          </a:prstGeom>
-          <a:noFill/>
-          <a:ln/>
-        </p:spPr>
-        <p:txBody>
-          <a:bodyPr wrap="square" lIns="0" tIns="0" rIns="0" bIns="0" rtlCol="0" anchor="t"/>
-          <a:lstStyle/>
-          <a:p>
-            <a:pPr algn="ctr" indent="0" marL="0">
-              <a:buNone/>
-            </a:pPr>
-            <a:r>
-              <a:rPr lang="en-US" sz="1800" b="1" dirty="0">
+              <a:t>Dreams generated from 10-bit counters, no stored examples</a:t>
+            </a:r>
+            <a:endParaRPr lang="en-US" sz="1400" dirty="0"/>
+          </a:p>
+          <a:p>
+            <a:pPr marL="342900" indent="-342900">
+              <a:spcAft>
+                <a:spcPts val="600"/>
+              </a:spcAft>
+              <a:buSzPct val="100000"/>
+              <a:buChar char="•"/>
+            </a:pPr>
+            <a:r>
+              <a:rPr lang="en-US" sz="1400" dirty="0">
                 <a:solidFill>
                   <a:schemeClr val="tx1"/>
                 </a:solidFill>
@@ -5303,77 +5213,20 @@
                 <a:ea typeface="Calibri" pitchFamily="34" charset="-122"/>
                 <a:cs typeface="Calibri" pitchFamily="34" charset="-120"/>
               </a:rPr>
-              <a:t>3</a:t>
-            </a:r>
-            <a:endParaRPr lang="en-US" sz="1800" dirty="0"/>
-          </a:p>
-        </p:txBody>
-      </p:sp>
-      <p:sp>
-        <p:nvSpPr>
-          <p:cNvPr id="16" name="Text 14"/>
-          <p:cNvSpPr txBox="1"/>
-          <p:nvPr/>
-        </p:nvSpPr>
-        <p:spPr>
-          <a:xfrm>
-            <a:off x="4800600" y="2148840"/>
-            <a:ext cx="1691640" cy="365760"/>
-          </a:xfrm>
-          <a:prstGeom prst="rect">
-            <a:avLst/>
-          </a:prstGeom>
-          <a:noFill/>
-          <a:ln/>
-        </p:spPr>
-        <p:txBody>
-          <a:bodyPr wrap="square" lIns="0" tIns="0" rIns="0" bIns="0" rtlCol="0" anchor="t"/>
-          <a:lstStyle/>
-          <a:p>
-            <a:pPr indent="0" marL="0">
-              <a:buNone/>
-            </a:pPr>
-            <a:r>
-              <a:rPr lang="en-US" sz="2000" b="1" dirty="0">
-                <a:solidFill>
-                  <a:schemeClr val="tx1"/>
-                </a:solidFill>
-                <a:latin typeface="Cambria" pitchFamily="34" charset="0"/>
-                <a:ea typeface="Cambria" pitchFamily="34" charset="-122"/>
-                <a:cs typeface="Cambria" pitchFamily="34" charset="-120"/>
-              </a:rPr>
-              <a:t>Then</a:t>
-            </a:r>
-            <a:endParaRPr lang="en-US" sz="2000" dirty="0"/>
-          </a:p>
-        </p:txBody>
-      </p:sp>
-      <p:sp>
-        <p:nvSpPr>
-          <p:cNvPr id="17" name="Text 15"/>
-          <p:cNvSpPr txBox="1"/>
-          <p:nvPr/>
-        </p:nvSpPr>
-        <p:spPr>
-          <a:xfrm>
-            <a:off x="4800600" y="2606040"/>
-            <a:ext cx="1691640" cy="1371600"/>
-          </a:xfrm>
-          <a:prstGeom prst="rect">
-            <a:avLst/>
-          </a:prstGeom>
-          <a:noFill/>
-          <a:ln/>
-        </p:spPr>
-        <p:txBody>
-          <a:bodyPr wrap="square" lIns="0" tIns="0" rIns="0" bIns="0" rtlCol="0" anchor="t"/>
-          <a:lstStyle/>
-          <a:p>
-            <a:pPr indent="0" marL="0">
-              <a:buNone/>
-            </a:pPr>
-            <a:r>
-              <a:rPr lang="en-US" sz="1300" dirty="0">
+              <a:t>A night that ends by itself</a:t>
+            </a:r>
+            <a:endParaRPr lang="en-US" sz="1400" dirty="0"/>
+          </a:p>
+          <a:p>
+            <a:pPr marL="342900" indent="-342900">
+              <a:spcAft>
+                <a:spcPts val="600"/>
+              </a:spcAft>
+              <a:buSzPct val="100000"/>
+              <a:buChar char="•"/>
+            </a:pPr>
+            <a:r>
+              <a:rPr lang="en-US" sz="1400" dirty="0">
                 <a:solidFill>
                   <a:schemeClr val="tx1"/>
                 </a:solidFill>
@@ -5381,90 +5234,17 @@
                 <a:ea typeface="Calibri" pitchFamily="34" charset="-122"/>
                 <a:cs typeface="Calibri" pitchFamily="34" charset="-120"/>
               </a:rPr>
-              <a:t>Learned word features, higher-fidelity dreams for clothing</a:t>
-            </a:r>
-            <a:endParaRPr lang="en-US" sz="1300" dirty="0"/>
-          </a:p>
-        </p:txBody>
-      </p:sp>
-      <p:sp>
-        <p:nvSpPr>
-          <p:cNvPr id="18" name="card"/>
-          <p:cNvSpPr/>
-          <p:nvPr/>
-        </p:nvSpPr>
-        <p:spPr>
-          <a:xfrm>
-            <a:off x="6766560" y="1371600"/>
-            <a:ext cx="1965960" cy="2651760"/>
-          </a:xfrm>
-          <a:prstGeom prst="roundRect">
-            <a:avLst>
-              <a:gd name="adj" fmla="val 4651"/>
-            </a:avLst>
-          </a:prstGeom>
-          <a:solidFill>
-            <a:schemeClr val="bg2"/>
-          </a:solidFill>
-          <a:ln w="12700">
-            <a:solidFill>
-              <a:schemeClr val="bg2"/>
-            </a:solidFill>
-            <a:prstDash val="solid"/>
-          </a:ln>
-        </p:spPr>
-      </p:sp>
-      <p:sp>
-        <p:nvSpPr>
-          <p:cNvPr id="19" name="marker"/>
-          <p:cNvSpPr/>
-          <p:nvPr/>
-        </p:nvSpPr>
-        <p:spPr>
-          <a:xfrm>
-            <a:off x="6903720" y="1508760"/>
-            <a:ext cx="502920" cy="502920"/>
-          </a:xfrm>
-          <a:prstGeom prst="ellipse">
-            <a:avLst/>
-          </a:prstGeom>
-          <a:solidFill>
-            <a:schemeClr val="accent5"/>
-          </a:solidFill>
-          <a:ln w="12700">
-            <a:solidFill>
-              <a:schemeClr val="accent5"/>
-            </a:solidFill>
-            <a:prstDash val="solid"/>
-          </a:ln>
-        </p:spPr>
-      </p:sp>
-      <p:sp>
-        <p:nvSpPr>
-          <p:cNvPr id="20" name="Text 18"/>
-          <p:cNvSpPr txBox="1"/>
-          <p:nvPr/>
-        </p:nvSpPr>
-        <p:spPr>
-          <a:xfrm>
-            <a:off x="6903720" y="1600200"/>
-            <a:ext cx="502920" cy="365760"/>
-          </a:xfrm>
-          <a:prstGeom prst="rect">
-            <a:avLst/>
-          </a:prstGeom>
-          <a:noFill/>
-          <a:ln/>
-        </p:spPr>
-        <p:txBody>
-          <a:bodyPr wrap="square" lIns="0" tIns="0" rIns="0" bIns="0" rtlCol="0" anchor="t"/>
-          <a:lstStyle/>
-          <a:p>
-            <a:pPr algn="ctr" indent="0" marL="0">
-              <a:buNone/>
-            </a:pPr>
-            <a:r>
-              <a:rPr lang="en-US" sz="1800" b="1" dirty="0">
+              <a:t>No multiplier, bit-exact from raw senses to decision</a:t>
+            </a:r>
+            <a:endParaRPr lang="en-US" sz="1400" dirty="0"/>
+          </a:p>
+          <a:p>
+            <a:pPr marL="342900" indent="-342900">
+              <a:buSzPct val="100000"/>
+              <a:buChar char="•"/>
+            </a:pPr>
+            <a:r>
+              <a:rPr lang="en-US" sz="1400" dirty="0">
                 <a:solidFill>
                   <a:schemeClr val="tx1"/>
                 </a:solidFill>
@@ -5472,124 +5252,7 @@
                 <a:ea typeface="Calibri" pitchFamily="34" charset="-122"/>
                 <a:cs typeface="Calibri" pitchFamily="34" charset="-120"/>
               </a:rPr>
-              <a:t>4</a:t>
-            </a:r>
-            <a:endParaRPr lang="en-US" sz="1800" dirty="0"/>
-          </a:p>
-        </p:txBody>
-      </p:sp>
-      <p:sp>
-        <p:nvSpPr>
-          <p:cNvPr id="21" name="Text 19"/>
-          <p:cNvSpPr txBox="1"/>
-          <p:nvPr/>
-        </p:nvSpPr>
-        <p:spPr>
-          <a:xfrm>
-            <a:off x="6903720" y="2148840"/>
-            <a:ext cx="1691640" cy="365760"/>
-          </a:xfrm>
-          <a:prstGeom prst="rect">
-            <a:avLst/>
-          </a:prstGeom>
-          <a:noFill/>
-          <a:ln/>
-        </p:spPr>
-        <p:txBody>
-          <a:bodyPr wrap="square" lIns="0" tIns="0" rIns="0" bIns="0" rtlCol="0" anchor="t"/>
-          <a:lstStyle/>
-          <a:p>
-            <a:pPr indent="0" marL="0">
-              <a:buNone/>
-            </a:pPr>
-            <a:r>
-              <a:rPr lang="en-US" sz="2000" b="1" dirty="0">
-                <a:solidFill>
-                  <a:schemeClr val="tx1"/>
-                </a:solidFill>
-                <a:latin typeface="Cambria" pitchFamily="34" charset="0"/>
-                <a:ea typeface="Cambria" pitchFamily="34" charset="-122"/>
-                <a:cs typeface="Cambria" pitchFamily="34" charset="-120"/>
-              </a:rPr>
-              <a:t>Later</a:t>
-            </a:r>
-            <a:endParaRPr lang="en-US" sz="2000" dirty="0"/>
-          </a:p>
-        </p:txBody>
-      </p:sp>
-      <p:sp>
-        <p:nvSpPr>
-          <p:cNvPr id="22" name="Text 20"/>
-          <p:cNvSpPr txBox="1"/>
-          <p:nvPr/>
-        </p:nvSpPr>
-        <p:spPr>
-          <a:xfrm>
-            <a:off x="6903720" y="2606040"/>
-            <a:ext cx="1691640" cy="1371600"/>
-          </a:xfrm>
-          <a:prstGeom prst="rect">
-            <a:avLst/>
-          </a:prstGeom>
-          <a:noFill/>
-          <a:ln/>
-        </p:spPr>
-        <p:txBody>
-          <a:bodyPr wrap="square" lIns="0" tIns="0" rIns="0" bIns="0" rtlCol="0" anchor="t"/>
-          <a:lstStyle/>
-          <a:p>
-            <a:pPr indent="0" marL="0">
-              <a:buNone/>
-            </a:pPr>
-            <a:r>
-              <a:rPr lang="en-US" sz="1300" dirty="0">
-                <a:solidFill>
-                  <a:schemeClr val="tx1"/>
-                </a:solidFill>
-                <a:latin typeface="Calibri" pitchFamily="34" charset="0"/>
-                <a:ea typeface="Calibri" pitchFamily="34" charset="-122"/>
-                <a:cs typeface="Calibri" pitchFamily="34" charset="-120"/>
-              </a:rPr>
-              <a:t>Write-up, demo video, area and power estimates; no fabrication yet</a:t>
-            </a:r>
-            <a:endParaRPr lang="en-US" sz="1300" dirty="0"/>
-          </a:p>
-        </p:txBody>
-      </p:sp>
-      <p:sp>
-        <p:nvSpPr>
-          <p:cNvPr id="23" name="Text 21"/>
-          <p:cNvSpPr txBox="1"/>
-          <p:nvPr/>
-        </p:nvSpPr>
-        <p:spPr>
-          <a:xfrm>
-            <a:off x="457200" y="4206240"/>
-            <a:ext cx="8229600" cy="457200"/>
-          </a:xfrm>
-          <a:prstGeom prst="rect">
-            <a:avLst/>
-          </a:prstGeom>
-          <a:noFill/>
-          <a:ln/>
-        </p:spPr>
-        <p:txBody>
-          <a:bodyPr wrap="square" lIns="0" tIns="0" rIns="0" bIns="0" rtlCol="0" anchor="t"/>
-          <a:lstStyle/>
-          <a:p>
-            <a:pPr indent="0" marL="0">
-              <a:buNone/>
-            </a:pPr>
-            <a:r>
-              <a:rPr lang="en-US" sz="1400" dirty="0">
-                <a:solidFill>
-                  <a:schemeClr val="tx1"/>
-                </a:solidFill>
-                <a:latin typeface="Calibri" pitchFamily="34" charset="0"/>
-                <a:ea typeface="Calibri" pitchFamily="34" charset="-122"/>
-                <a:cs typeface="Calibri" pitchFamily="34" charset="-120"/>
-              </a:rPr>
-              <a:t>Horizon: a provable result within 6 to 8 months, then shrink and attract investors.</a:t>
+              <a:t>Ahead of HDC in our test after 5 stages: digits +2.2, sound +5.7</a:t>
             </a:r>
             <a:endParaRPr lang="en-US" sz="1400" dirty="0"/>
           </a:p>
@@ -5675,6 +5338,832 @@
         </p:nvSpPr>
         <p:spPr>
           <a:xfrm>
+            <a:off x="457200" y="274320"/>
+            <a:ext cx="8229600" cy="822960"/>
+          </a:xfrm>
+          <a:prstGeom prst="rect">
+            <a:avLst/>
+          </a:prstGeom>
+          <a:noFill/>
+          <a:ln/>
+        </p:spPr>
+        <p:txBody>
+          <a:bodyPr wrap="square" lIns="0" tIns="0" rIns="0" bIns="0" rtlCol="0" anchor="ctr"/>
+          <a:lstStyle/>
+          <a:p>
+            <a:pPr algn="l" indent="0" marL="0">
+              <a:buNone/>
+            </a:pPr>
+            <a:r>
+              <a:rPr lang="en-US" sz="3000" b="1" dirty="0">
+                <a:solidFill>
+                  <a:schemeClr val="tx1"/>
+                </a:solidFill>
+                <a:latin typeface="Cambria" pitchFamily="34" charset="0"/>
+                <a:ea typeface="Cambria" pitchFamily="34" charset="-122"/>
+                <a:cs typeface="Cambria" pitchFamily="34" charset="-120"/>
+              </a:rPr>
+              <a:t>What comes next</a:t>
+            </a:r>
+            <a:endParaRPr lang="en-US" sz="3000" dirty="0"/>
+          </a:p>
+        </p:txBody>
+      </p:sp>
+      <p:sp>
+        <p:nvSpPr>
+          <p:cNvPr id="3" name="card"/>
+          <p:cNvSpPr/>
+          <p:nvPr/>
+        </p:nvSpPr>
+        <p:spPr>
+          <a:xfrm>
+            <a:off x="457200" y="1371600"/>
+            <a:ext cx="1965960" cy="2651760"/>
+          </a:xfrm>
+          <a:prstGeom prst="roundRect">
+            <a:avLst>
+              <a:gd name="adj" fmla="val 4651"/>
+            </a:avLst>
+          </a:prstGeom>
+          <a:solidFill>
+            <a:schemeClr val="bg2"/>
+          </a:solidFill>
+          <a:ln w="12700">
+            <a:solidFill>
+              <a:schemeClr val="bg2"/>
+            </a:solidFill>
+            <a:prstDash val="solid"/>
+          </a:ln>
+        </p:spPr>
+      </p:sp>
+      <p:sp>
+        <p:nvSpPr>
+          <p:cNvPr id="4" name="marker"/>
+          <p:cNvSpPr/>
+          <p:nvPr/>
+        </p:nvSpPr>
+        <p:spPr>
+          <a:xfrm>
+            <a:off x="594360" y="1508760"/>
+            <a:ext cx="502920" cy="502920"/>
+          </a:xfrm>
+          <a:prstGeom prst="ellipse">
+            <a:avLst/>
+          </a:prstGeom>
+          <a:solidFill>
+            <a:schemeClr val="accent3"/>
+          </a:solidFill>
+          <a:ln w="12700">
+            <a:solidFill>
+              <a:schemeClr val="accent3"/>
+            </a:solidFill>
+            <a:prstDash val="solid"/>
+          </a:ln>
+        </p:spPr>
+      </p:sp>
+      <p:sp>
+        <p:nvSpPr>
+          <p:cNvPr id="5" name="Text 3"/>
+          <p:cNvSpPr txBox="1"/>
+          <p:nvPr/>
+        </p:nvSpPr>
+        <p:spPr>
+          <a:xfrm>
+            <a:off x="594360" y="1600200"/>
+            <a:ext cx="502920" cy="365760"/>
+          </a:xfrm>
+          <a:prstGeom prst="rect">
+            <a:avLst/>
+          </a:prstGeom>
+          <a:noFill/>
+          <a:ln/>
+        </p:spPr>
+        <p:txBody>
+          <a:bodyPr wrap="square" lIns="0" tIns="0" rIns="0" bIns="0" rtlCol="0" anchor="t"/>
+          <a:lstStyle/>
+          <a:p>
+            <a:pPr algn="ctr" indent="0" marL="0">
+              <a:buNone/>
+            </a:pPr>
+            <a:r>
+              <a:rPr lang="en-US" sz="1800" b="1" dirty="0">
+                <a:solidFill>
+                  <a:schemeClr val="tx1"/>
+                </a:solidFill>
+                <a:latin typeface="Calibri" pitchFamily="34" charset="0"/>
+                <a:ea typeface="Calibri" pitchFamily="34" charset="-122"/>
+                <a:cs typeface="Calibri" pitchFamily="34" charset="-120"/>
+              </a:rPr>
+              <a:t>1</a:t>
+            </a:r>
+            <a:endParaRPr lang="en-US" sz="1800" dirty="0"/>
+          </a:p>
+        </p:txBody>
+      </p:sp>
+      <p:sp>
+        <p:nvSpPr>
+          <p:cNvPr id="6" name="Text 4"/>
+          <p:cNvSpPr txBox="1"/>
+          <p:nvPr/>
+        </p:nvSpPr>
+        <p:spPr>
+          <a:xfrm>
+            <a:off x="594360" y="2148840"/>
+            <a:ext cx="1691640" cy="365760"/>
+          </a:xfrm>
+          <a:prstGeom prst="rect">
+            <a:avLst/>
+          </a:prstGeom>
+          <a:noFill/>
+          <a:ln/>
+        </p:spPr>
+        <p:txBody>
+          <a:bodyPr wrap="square" lIns="0" tIns="0" rIns="0" bIns="0" rtlCol="0" anchor="t"/>
+          <a:lstStyle/>
+          <a:p>
+            <a:pPr indent="0" marL="0">
+              <a:buNone/>
+            </a:pPr>
+            <a:r>
+              <a:rPr lang="en-US" sz="2000" b="1" dirty="0">
+                <a:solidFill>
+                  <a:schemeClr val="tx1"/>
+                </a:solidFill>
+                <a:latin typeface="Cambria" pitchFamily="34" charset="0"/>
+                <a:ea typeface="Cambria" pitchFamily="34" charset="-122"/>
+                <a:cs typeface="Cambria" pitchFamily="34" charset="-120"/>
+              </a:rPr>
+              <a:t>Done</a:t>
+            </a:r>
+            <a:endParaRPr lang="en-US" sz="2000" dirty="0"/>
+          </a:p>
+        </p:txBody>
+      </p:sp>
+      <p:sp>
+        <p:nvSpPr>
+          <p:cNvPr id="7" name="Text 5"/>
+          <p:cNvSpPr txBox="1"/>
+          <p:nvPr/>
+        </p:nvSpPr>
+        <p:spPr>
+          <a:xfrm>
+            <a:off x="594360" y="2606040"/>
+            <a:ext cx="1691640" cy="1371600"/>
+          </a:xfrm>
+          <a:prstGeom prst="rect">
+            <a:avLst/>
+          </a:prstGeom>
+          <a:noFill/>
+          <a:ln/>
+        </p:spPr>
+        <p:txBody>
+          <a:bodyPr wrap="square" lIns="0" tIns="0" rIns="0" bIns="0" rtlCol="0" anchor="t"/>
+          <a:lstStyle/>
+          <a:p>
+            <a:pPr indent="0" marL="0">
+              <a:buNone/>
+            </a:pPr>
+            <a:r>
+              <a:rPr lang="en-US" sz="1300" dirty="0">
+                <a:solidFill>
+                  <a:schemeClr val="tx1"/>
+                </a:solidFill>
+                <a:latin typeface="Calibri" pitchFamily="34" charset="0"/>
+                <a:ea typeface="Calibri" pitchFamily="34" charset="-122"/>
+                <a:cs typeface="Calibri" pitchFamily="34" charset="-120"/>
+              </a:rPr>
+              <a:t>Model, RTL, 21 checks, slow-table option, FPGA fit, SKY130 layout estimate</a:t>
+            </a:r>
+            <a:endParaRPr lang="en-US" sz="1300" dirty="0"/>
+          </a:p>
+        </p:txBody>
+      </p:sp>
+      <p:sp>
+        <p:nvSpPr>
+          <p:cNvPr id="8" name="card"/>
+          <p:cNvSpPr/>
+          <p:nvPr/>
+        </p:nvSpPr>
+        <p:spPr>
+          <a:xfrm>
+            <a:off x="2560320" y="1371600"/>
+            <a:ext cx="1965960" cy="2651760"/>
+          </a:xfrm>
+          <a:prstGeom prst="roundRect">
+            <a:avLst>
+              <a:gd name="adj" fmla="val 4651"/>
+            </a:avLst>
+          </a:prstGeom>
+          <a:solidFill>
+            <a:schemeClr val="bg2"/>
+          </a:solidFill>
+          <a:ln w="12700">
+            <a:solidFill>
+              <a:schemeClr val="bg2"/>
+            </a:solidFill>
+            <a:prstDash val="solid"/>
+          </a:ln>
+        </p:spPr>
+      </p:sp>
+      <p:sp>
+        <p:nvSpPr>
+          <p:cNvPr id="9" name="marker"/>
+          <p:cNvSpPr/>
+          <p:nvPr/>
+        </p:nvSpPr>
+        <p:spPr>
+          <a:xfrm>
+            <a:off x="2697480" y="1508760"/>
+            <a:ext cx="502920" cy="502920"/>
+          </a:xfrm>
+          <a:prstGeom prst="ellipse">
+            <a:avLst/>
+          </a:prstGeom>
+          <a:solidFill>
+            <a:schemeClr val="accent1"/>
+          </a:solidFill>
+          <a:ln w="12700">
+            <a:solidFill>
+              <a:schemeClr val="accent1"/>
+            </a:solidFill>
+            <a:prstDash val="solid"/>
+          </a:ln>
+        </p:spPr>
+      </p:sp>
+      <p:sp>
+        <p:nvSpPr>
+          <p:cNvPr id="10" name="Text 8"/>
+          <p:cNvSpPr txBox="1"/>
+          <p:nvPr/>
+        </p:nvSpPr>
+        <p:spPr>
+          <a:xfrm>
+            <a:off x="2697480" y="1600200"/>
+            <a:ext cx="502920" cy="365760"/>
+          </a:xfrm>
+          <a:prstGeom prst="rect">
+            <a:avLst/>
+          </a:prstGeom>
+          <a:noFill/>
+          <a:ln/>
+        </p:spPr>
+        <p:txBody>
+          <a:bodyPr wrap="square" lIns="0" tIns="0" rIns="0" bIns="0" rtlCol="0" anchor="t"/>
+          <a:lstStyle/>
+          <a:p>
+            <a:pPr algn="ctr" indent="0" marL="0">
+              <a:buNone/>
+            </a:pPr>
+            <a:r>
+              <a:rPr lang="en-US" sz="1800" b="1" dirty="0">
+                <a:solidFill>
+                  <a:schemeClr val="tx1"/>
+                </a:solidFill>
+                <a:latin typeface="Calibri" pitchFamily="34" charset="0"/>
+                <a:ea typeface="Calibri" pitchFamily="34" charset="-122"/>
+                <a:cs typeface="Calibri" pitchFamily="34" charset="-120"/>
+              </a:rPr>
+              <a:t>2</a:t>
+            </a:r>
+            <a:endParaRPr lang="en-US" sz="1800" dirty="0"/>
+          </a:p>
+        </p:txBody>
+      </p:sp>
+      <p:sp>
+        <p:nvSpPr>
+          <p:cNvPr id="11" name="Text 9"/>
+          <p:cNvSpPr txBox="1"/>
+          <p:nvPr/>
+        </p:nvSpPr>
+        <p:spPr>
+          <a:xfrm>
+            <a:off x="2697480" y="2148840"/>
+            <a:ext cx="1691640" cy="365760"/>
+          </a:xfrm>
+          <a:prstGeom prst="rect">
+            <a:avLst/>
+          </a:prstGeom>
+          <a:noFill/>
+          <a:ln/>
+        </p:spPr>
+        <p:txBody>
+          <a:bodyPr wrap="square" lIns="0" tIns="0" rIns="0" bIns="0" rtlCol="0" anchor="t"/>
+          <a:lstStyle/>
+          <a:p>
+            <a:pPr indent="0" marL="0">
+              <a:buNone/>
+            </a:pPr>
+            <a:r>
+              <a:rPr lang="en-US" sz="2000" b="1" dirty="0">
+                <a:solidFill>
+                  <a:schemeClr val="tx1"/>
+                </a:solidFill>
+                <a:latin typeface="Cambria" pitchFamily="34" charset="0"/>
+                <a:ea typeface="Cambria" pitchFamily="34" charset="-122"/>
+                <a:cs typeface="Cambria" pitchFamily="34" charset="-120"/>
+              </a:rPr>
+              <a:t>Next</a:t>
+            </a:r>
+            <a:endParaRPr lang="en-US" sz="2000" dirty="0"/>
+          </a:p>
+        </p:txBody>
+      </p:sp>
+      <p:sp>
+        <p:nvSpPr>
+          <p:cNvPr id="12" name="Text 10"/>
+          <p:cNvSpPr txBox="1"/>
+          <p:nvPr/>
+        </p:nvSpPr>
+        <p:spPr>
+          <a:xfrm>
+            <a:off x="2697480" y="2606040"/>
+            <a:ext cx="1691640" cy="1371600"/>
+          </a:xfrm>
+          <a:prstGeom prst="rect">
+            <a:avLst/>
+          </a:prstGeom>
+          <a:noFill/>
+          <a:ln/>
+        </p:spPr>
+        <p:txBody>
+          <a:bodyPr wrap="square" lIns="0" tIns="0" rIns="0" bIns="0" rtlCol="0" anchor="t"/>
+          <a:lstStyle/>
+          <a:p>
+            <a:pPr indent="0" marL="0">
+              <a:buNone/>
+            </a:pPr>
+            <a:r>
+              <a:rPr lang="en-US" sz="1300" dirty="0">
+                <a:solidFill>
+                  <a:schemeClr val="tx1"/>
+                </a:solidFill>
+                <a:latin typeface="Calibri" pitchFamily="34" charset="0"/>
+                <a:ea typeface="Calibri" pitchFamily="34" charset="-122"/>
+                <a:cs typeface="Calibri" pitchFamily="34" charset="-120"/>
+              </a:rPr>
+              <a:t>First run on the real Tang Nano: the first MEASURED numbers</a:t>
+            </a:r>
+            <a:endParaRPr lang="en-US" sz="1300" dirty="0"/>
+          </a:p>
+        </p:txBody>
+      </p:sp>
+      <p:sp>
+        <p:nvSpPr>
+          <p:cNvPr id="13" name="card"/>
+          <p:cNvSpPr/>
+          <p:nvPr/>
+        </p:nvSpPr>
+        <p:spPr>
+          <a:xfrm>
+            <a:off x="4663440" y="1371600"/>
+            <a:ext cx="1965960" cy="2651760"/>
+          </a:xfrm>
+          <a:prstGeom prst="roundRect">
+            <a:avLst>
+              <a:gd name="adj" fmla="val 4651"/>
+            </a:avLst>
+          </a:prstGeom>
+          <a:solidFill>
+            <a:schemeClr val="bg2"/>
+          </a:solidFill>
+          <a:ln w="12700">
+            <a:solidFill>
+              <a:schemeClr val="bg2"/>
+            </a:solidFill>
+            <a:prstDash val="solid"/>
+          </a:ln>
+        </p:spPr>
+      </p:sp>
+      <p:sp>
+        <p:nvSpPr>
+          <p:cNvPr id="14" name="marker"/>
+          <p:cNvSpPr/>
+          <p:nvPr/>
+        </p:nvSpPr>
+        <p:spPr>
+          <a:xfrm>
+            <a:off x="4800600" y="1508760"/>
+            <a:ext cx="502920" cy="502920"/>
+          </a:xfrm>
+          <a:prstGeom prst="ellipse">
+            <a:avLst/>
+          </a:prstGeom>
+          <a:solidFill>
+            <a:schemeClr val="accent2"/>
+          </a:solidFill>
+          <a:ln w="12700">
+            <a:solidFill>
+              <a:schemeClr val="accent2"/>
+            </a:solidFill>
+            <a:prstDash val="solid"/>
+          </a:ln>
+        </p:spPr>
+      </p:sp>
+      <p:sp>
+        <p:nvSpPr>
+          <p:cNvPr id="15" name="Text 13"/>
+          <p:cNvSpPr txBox="1"/>
+          <p:nvPr/>
+        </p:nvSpPr>
+        <p:spPr>
+          <a:xfrm>
+            <a:off x="4800600" y="1600200"/>
+            <a:ext cx="502920" cy="365760"/>
+          </a:xfrm>
+          <a:prstGeom prst="rect">
+            <a:avLst/>
+          </a:prstGeom>
+          <a:noFill/>
+          <a:ln/>
+        </p:spPr>
+        <p:txBody>
+          <a:bodyPr wrap="square" lIns="0" tIns="0" rIns="0" bIns="0" rtlCol="0" anchor="t"/>
+          <a:lstStyle/>
+          <a:p>
+            <a:pPr algn="ctr" indent="0" marL="0">
+              <a:buNone/>
+            </a:pPr>
+            <a:r>
+              <a:rPr lang="en-US" sz="1800" b="1" dirty="0">
+                <a:solidFill>
+                  <a:schemeClr val="tx1"/>
+                </a:solidFill>
+                <a:latin typeface="Calibri" pitchFamily="34" charset="0"/>
+                <a:ea typeface="Calibri" pitchFamily="34" charset="-122"/>
+                <a:cs typeface="Calibri" pitchFamily="34" charset="-120"/>
+              </a:rPr>
+              <a:t>3</a:t>
+            </a:r>
+            <a:endParaRPr lang="en-US" sz="1800" dirty="0"/>
+          </a:p>
+        </p:txBody>
+      </p:sp>
+      <p:sp>
+        <p:nvSpPr>
+          <p:cNvPr id="16" name="Text 14"/>
+          <p:cNvSpPr txBox="1"/>
+          <p:nvPr/>
+        </p:nvSpPr>
+        <p:spPr>
+          <a:xfrm>
+            <a:off x="4800600" y="2148840"/>
+            <a:ext cx="1691640" cy="365760"/>
+          </a:xfrm>
+          <a:prstGeom prst="rect">
+            <a:avLst/>
+          </a:prstGeom>
+          <a:noFill/>
+          <a:ln/>
+        </p:spPr>
+        <p:txBody>
+          <a:bodyPr wrap="square" lIns="0" tIns="0" rIns="0" bIns="0" rtlCol="0" anchor="t"/>
+          <a:lstStyle/>
+          <a:p>
+            <a:pPr indent="0" marL="0">
+              <a:buNone/>
+            </a:pPr>
+            <a:r>
+              <a:rPr lang="en-US" sz="2000" b="1" dirty="0">
+                <a:solidFill>
+                  <a:schemeClr val="tx1"/>
+                </a:solidFill>
+                <a:latin typeface="Cambria" pitchFamily="34" charset="0"/>
+                <a:ea typeface="Cambria" pitchFamily="34" charset="-122"/>
+                <a:cs typeface="Cambria" pitchFamily="34" charset="-120"/>
+              </a:rPr>
+              <a:t>Then</a:t>
+            </a:r>
+            <a:endParaRPr lang="en-US" sz="2000" dirty="0"/>
+          </a:p>
+        </p:txBody>
+      </p:sp>
+      <p:sp>
+        <p:nvSpPr>
+          <p:cNvPr id="17" name="Text 15"/>
+          <p:cNvSpPr txBox="1"/>
+          <p:nvPr/>
+        </p:nvSpPr>
+        <p:spPr>
+          <a:xfrm>
+            <a:off x="4800600" y="2606040"/>
+            <a:ext cx="1691640" cy="1371600"/>
+          </a:xfrm>
+          <a:prstGeom prst="rect">
+            <a:avLst/>
+          </a:prstGeom>
+          <a:noFill/>
+          <a:ln/>
+        </p:spPr>
+        <p:txBody>
+          <a:bodyPr wrap="square" lIns="0" tIns="0" rIns="0" bIns="0" rtlCol="0" anchor="t"/>
+          <a:lstStyle/>
+          <a:p>
+            <a:pPr indent="0" marL="0">
+              <a:buNone/>
+            </a:pPr>
+            <a:r>
+              <a:rPr lang="en-US" sz="1300" dirty="0">
+                <a:solidFill>
+                  <a:schemeClr val="tx1"/>
+                </a:solidFill>
+                <a:latin typeface="Calibri" pitchFamily="34" charset="0"/>
+                <a:ea typeface="Calibri" pitchFamily="34" charset="-122"/>
+                <a:cs typeface="Calibri" pitchFamily="34" charset="-120"/>
+              </a:rPr>
+              <a:t>Learned word features, higher-fidelity dreams for clothing</a:t>
+            </a:r>
+            <a:endParaRPr lang="en-US" sz="1300" dirty="0"/>
+          </a:p>
+        </p:txBody>
+      </p:sp>
+      <p:sp>
+        <p:nvSpPr>
+          <p:cNvPr id="18" name="card"/>
+          <p:cNvSpPr/>
+          <p:nvPr/>
+        </p:nvSpPr>
+        <p:spPr>
+          <a:xfrm>
+            <a:off x="6766560" y="1371600"/>
+            <a:ext cx="1965960" cy="2651760"/>
+          </a:xfrm>
+          <a:prstGeom prst="roundRect">
+            <a:avLst>
+              <a:gd name="adj" fmla="val 4651"/>
+            </a:avLst>
+          </a:prstGeom>
+          <a:solidFill>
+            <a:schemeClr val="bg2"/>
+          </a:solidFill>
+          <a:ln w="12700">
+            <a:solidFill>
+              <a:schemeClr val="bg2"/>
+            </a:solidFill>
+            <a:prstDash val="solid"/>
+          </a:ln>
+        </p:spPr>
+      </p:sp>
+      <p:sp>
+        <p:nvSpPr>
+          <p:cNvPr id="19" name="marker"/>
+          <p:cNvSpPr/>
+          <p:nvPr/>
+        </p:nvSpPr>
+        <p:spPr>
+          <a:xfrm>
+            <a:off x="6903720" y="1508760"/>
+            <a:ext cx="502920" cy="502920"/>
+          </a:xfrm>
+          <a:prstGeom prst="ellipse">
+            <a:avLst/>
+          </a:prstGeom>
+          <a:solidFill>
+            <a:schemeClr val="accent5"/>
+          </a:solidFill>
+          <a:ln w="12700">
+            <a:solidFill>
+              <a:schemeClr val="accent5"/>
+            </a:solidFill>
+            <a:prstDash val="solid"/>
+          </a:ln>
+        </p:spPr>
+      </p:sp>
+      <p:sp>
+        <p:nvSpPr>
+          <p:cNvPr id="20" name="Text 18"/>
+          <p:cNvSpPr txBox="1"/>
+          <p:nvPr/>
+        </p:nvSpPr>
+        <p:spPr>
+          <a:xfrm>
+            <a:off x="6903720" y="1600200"/>
+            <a:ext cx="502920" cy="365760"/>
+          </a:xfrm>
+          <a:prstGeom prst="rect">
+            <a:avLst/>
+          </a:prstGeom>
+          <a:noFill/>
+          <a:ln/>
+        </p:spPr>
+        <p:txBody>
+          <a:bodyPr wrap="square" lIns="0" tIns="0" rIns="0" bIns="0" rtlCol="0" anchor="t"/>
+          <a:lstStyle/>
+          <a:p>
+            <a:pPr algn="ctr" indent="0" marL="0">
+              <a:buNone/>
+            </a:pPr>
+            <a:r>
+              <a:rPr lang="en-US" sz="1800" b="1" dirty="0">
+                <a:solidFill>
+                  <a:schemeClr val="tx1"/>
+                </a:solidFill>
+                <a:latin typeface="Calibri" pitchFamily="34" charset="0"/>
+                <a:ea typeface="Calibri" pitchFamily="34" charset="-122"/>
+                <a:cs typeface="Calibri" pitchFamily="34" charset="-120"/>
+              </a:rPr>
+              <a:t>4</a:t>
+            </a:r>
+            <a:endParaRPr lang="en-US" sz="1800" dirty="0"/>
+          </a:p>
+        </p:txBody>
+      </p:sp>
+      <p:sp>
+        <p:nvSpPr>
+          <p:cNvPr id="21" name="Text 19"/>
+          <p:cNvSpPr txBox="1"/>
+          <p:nvPr/>
+        </p:nvSpPr>
+        <p:spPr>
+          <a:xfrm>
+            <a:off x="6903720" y="2148840"/>
+            <a:ext cx="1691640" cy="365760"/>
+          </a:xfrm>
+          <a:prstGeom prst="rect">
+            <a:avLst/>
+          </a:prstGeom>
+          <a:noFill/>
+          <a:ln/>
+        </p:spPr>
+        <p:txBody>
+          <a:bodyPr wrap="square" lIns="0" tIns="0" rIns="0" bIns="0" rtlCol="0" anchor="t"/>
+          <a:lstStyle/>
+          <a:p>
+            <a:pPr indent="0" marL="0">
+              <a:buNone/>
+            </a:pPr>
+            <a:r>
+              <a:rPr lang="en-US" sz="2000" b="1" dirty="0">
+                <a:solidFill>
+                  <a:schemeClr val="tx1"/>
+                </a:solidFill>
+                <a:latin typeface="Cambria" pitchFamily="34" charset="0"/>
+                <a:ea typeface="Cambria" pitchFamily="34" charset="-122"/>
+                <a:cs typeface="Cambria" pitchFamily="34" charset="-120"/>
+              </a:rPr>
+              <a:t>Later</a:t>
+            </a:r>
+            <a:endParaRPr lang="en-US" sz="2000" dirty="0"/>
+          </a:p>
+        </p:txBody>
+      </p:sp>
+      <p:sp>
+        <p:nvSpPr>
+          <p:cNvPr id="22" name="Text 20"/>
+          <p:cNvSpPr txBox="1"/>
+          <p:nvPr/>
+        </p:nvSpPr>
+        <p:spPr>
+          <a:xfrm>
+            <a:off x="6903720" y="2606040"/>
+            <a:ext cx="1691640" cy="1371600"/>
+          </a:xfrm>
+          <a:prstGeom prst="rect">
+            <a:avLst/>
+          </a:prstGeom>
+          <a:noFill/>
+          <a:ln/>
+        </p:spPr>
+        <p:txBody>
+          <a:bodyPr wrap="square" lIns="0" tIns="0" rIns="0" bIns="0" rtlCol="0" anchor="t"/>
+          <a:lstStyle/>
+          <a:p>
+            <a:pPr indent="0" marL="0">
+              <a:buNone/>
+            </a:pPr>
+            <a:r>
+              <a:rPr lang="en-US" sz="1300" dirty="0">
+                <a:solidFill>
+                  <a:schemeClr val="tx1"/>
+                </a:solidFill>
+                <a:latin typeface="Calibri" pitchFamily="34" charset="0"/>
+                <a:ea typeface="Calibri" pitchFamily="34" charset="-122"/>
+                <a:cs typeface="Calibri" pitchFamily="34" charset="-120"/>
+              </a:rPr>
+              <a:t>Write-up, demo video, area and power estimates; no fabrication yet</a:t>
+            </a:r>
+            <a:endParaRPr lang="en-US" sz="1300" dirty="0"/>
+          </a:p>
+        </p:txBody>
+      </p:sp>
+      <p:sp>
+        <p:nvSpPr>
+          <p:cNvPr id="23" name="Text 21"/>
+          <p:cNvSpPr txBox="1"/>
+          <p:nvPr/>
+        </p:nvSpPr>
+        <p:spPr>
+          <a:xfrm>
+            <a:off x="457200" y="4206240"/>
+            <a:ext cx="8229600" cy="457200"/>
+          </a:xfrm>
+          <a:prstGeom prst="rect">
+            <a:avLst/>
+          </a:prstGeom>
+          <a:noFill/>
+          <a:ln/>
+        </p:spPr>
+        <p:txBody>
+          <a:bodyPr wrap="square" lIns="0" tIns="0" rIns="0" bIns="0" rtlCol="0" anchor="t"/>
+          <a:lstStyle/>
+          <a:p>
+            <a:pPr indent="0" marL="0">
+              <a:buNone/>
+            </a:pPr>
+            <a:r>
+              <a:rPr lang="en-US" sz="1400" dirty="0">
+                <a:solidFill>
+                  <a:schemeClr val="tx1"/>
+                </a:solidFill>
+                <a:latin typeface="Calibri" pitchFamily="34" charset="0"/>
+                <a:ea typeface="Calibri" pitchFamily="34" charset="-122"/>
+                <a:cs typeface="Calibri" pitchFamily="34" charset="-120"/>
+              </a:rPr>
+              <a:t>Horizon: a provable result within 6 to 8 months, then shrink and attract investors.</a:t>
+            </a:r>
+            <a:endParaRPr lang="en-US" sz="1400" dirty="0"/>
+          </a:p>
+        </p:txBody>
+      </p:sp>
+      <p:sp>
+        <p:nvSpPr>
+          <p:cNvPr id="25" name="Slide Number Placeholder 0"/>
+          <p:cNvSpPr>
+            <a:spLocks noGrp="1"/>
+          </p:cNvSpPr>
+          <p:nvPr>
+            <p:ph type="sldNum" sz="quarter" idx="4294967295"/>
+          </p:nvPr>
+        </p:nvSpPr>
+        <p:spPr>
+          <a:xfrm>
+            <a:off x="8412480" y="4800600"/>
+            <a:ext cx="800000" cy="300000"/>
+          </a:xfrm>
+          <a:prstGeom prst="rect">
+            <a:avLst/>
+          </a:prstGeom>
+          <a:extLst>
+            <a:ext uri="{C572A759-6A51-4108-AA02-DFA0A04FC94B}">
+              <ma14:wrappingTextBoxFlag xmlns:ma14="http://schemas.microsoft.com/office/mac/drawingml/2011/main" val="0"/>
+            </a:ext>
+          </a:extLst>
+        </p:spPr>
+        <p:txBody>
+          <a:bodyPr/>
+          <a:lstStyle>
+            <a:lvl1pPr>
+              <a:defRPr sz="1000">
+                <a:solidFill>
+                  <a:schemeClr val="accent6"/>
+                </a:solidFill>
+              </a:defRPr>
+            </a:lvl1pPr>
+          </a:lstStyle>
+          <a:p>
+            <a:pPr algn="l"/>
+            <a:fld id="{F7021451-1387-4CA6-816F-3879F97B5CBC}" type="slidenum">
+              <a:rPr b="0" lang="en-US"/>
+              <a:t>13</a:t>
+            </a:fld>
+            <a:endParaRPr lang="en-US"/>
+          </a:p>
+        </p:txBody>
+      </p:sp>
+    </p:spTree>
+  </p:cSld>
+  <p:clrMapOvr>
+    <a:masterClrMapping/>
+  </p:clrMapOvr>
+</p:sld>
+</file>
+
+<file path=ppt/slides/slide14.xml><?xml version="1.0" encoding="utf-8"?>
+<p:sld xmlns:a="http://schemas.openxmlformats.org/drawingml/2006/main" xmlns:r="http://schemas.openxmlformats.org/officeDocument/2006/relationships" xmlns:p="http://schemas.openxmlformats.org/presentationml/2006/main">
+  <p:cSld name="Slide 14">
+    <p:spTree>
+      <p:nvGrpSpPr>
+        <p:cNvPr id="1" name=""/>
+        <p:cNvGrpSpPr/>
+        <p:nvPr/>
+      </p:nvGrpSpPr>
+      <p:grpSpPr>
+        <a:xfrm>
+          <a:off x="0" y="0"/>
+          <a:ext cx="0" cy="0"/>
+          <a:chOff x="0" y="0"/>
+          <a:chExt cx="0" cy="0"/>
+        </a:xfrm>
+      </p:grpSpPr>
+      <p:sp>
+        <p:nvSpPr>
+          <p:cNvPr id="2" name="Text 0"/>
+          <p:cNvSpPr/>
+          <p:nvPr>
+            <p:ph idx="100" type="title" hasCustomPrompt="1"/>
+          </p:nvPr>
+        </p:nvSpPr>
+        <p:spPr>
+          <a:xfrm>
             <a:off x="548640" y="1371600"/>
             <a:ext cx="8046720" cy="1280160"/>
           </a:xfrm>
@@ -8180,7 +8669,7 @@
                 <a:ea typeface="Cambria" pitchFamily="34" charset="-122"/>
                 <a:cs typeface="Cambria" pitchFamily="34" charset="-120"/>
               </a:rPr>
-              <a:t>Small, cheap, and no multiplier</a:t>
+              <a:t>We found what limited the scores</a:t>
             </a:r>
             <a:endParaRPr lang="en-US" sz="3000" dirty="0"/>
           </a:p>
@@ -8194,12 +8683,12 @@
         </p:nvSpPr>
         <p:spPr>
           <a:xfrm>
-            <a:off x="457200" y="1188720"/>
-            <a:ext cx="4023360" cy="1554480"/>
+            <a:off x="457200" y="1280160"/>
+            <a:ext cx="8229600" cy="749808"/>
           </a:xfrm>
           <a:prstGeom prst="roundRect">
             <a:avLst>
-              <a:gd name="adj" fmla="val 5882"/>
+              <a:gd name="adj" fmla="val 12195"/>
             </a:avLst>
           </a:prstGeom>
           <a:solidFill>
@@ -8215,42 +8704,28 @@
       </p:sp>
       <p:sp>
         <p:nvSpPr>
-          <p:cNvPr id="4" name="Text 2"/>
-          <p:cNvSpPr txBox="1"/>
-          <p:nvPr/>
-        </p:nvSpPr>
-        <p:spPr>
-          <a:xfrm>
-            <a:off x="640080" y="1298448"/>
-            <a:ext cx="3657600" cy="640080"/>
-          </a:xfrm>
-          <a:prstGeom prst="rect">
-            <a:avLst/>
-          </a:prstGeom>
-          <a:noFill/>
-          <a:ln/>
-        </p:spPr>
-        <p:txBody>
-          <a:bodyPr wrap="square" lIns="0" tIns="0" rIns="0" bIns="0" rtlCol="0" anchor="t"/>
-          <a:lstStyle/>
-          <a:p>
-            <a:pPr indent="0" marL="0">
-              <a:buNone/>
-            </a:pPr>
-            <a:r>
-              <a:rPr lang="en-US" sz="3400" b="1" dirty="0">
-                <a:solidFill>
-                  <a:schemeClr val="accent2"/>
-                </a:solidFill>
-                <a:latin typeface="Cambria" pitchFamily="34" charset="0"/>
-                <a:ea typeface="Cambria" pitchFamily="34" charset="-122"/>
-                <a:cs typeface="Cambria" pitchFamily="34" charset="-120"/>
-              </a:rPr>
-              <a:t>84 KB</a:t>
-            </a:r>
-            <a:endParaRPr lang="en-US" sz="3400" dirty="0"/>
-          </a:p>
-        </p:txBody>
+          <p:cNvPr id="4" name="marker"/>
+          <p:cNvSpPr/>
+          <p:nvPr/>
+        </p:nvSpPr>
+        <p:spPr>
+          <a:xfrm>
+            <a:off x="594360" y="1417320"/>
+            <a:ext cx="457200" cy="457200"/>
+          </a:xfrm>
+          <a:prstGeom prst="ellipse">
+            <a:avLst/>
+          </a:prstGeom>
+          <a:solidFill>
+            <a:schemeClr val="accent1"/>
+          </a:solidFill>
+          <a:ln w="12700">
+            <a:solidFill>
+              <a:schemeClr val="accent1"/>
+            </a:solidFill>
+            <a:prstDash val="solid"/>
+          </a:ln>
+        </p:spPr>
       </p:sp>
       <p:sp>
         <p:nvSpPr>
@@ -8260,8 +8735,8 @@
         </p:nvSpPr>
         <p:spPr>
           <a:xfrm>
-            <a:off x="640080" y="1938528"/>
-            <a:ext cx="3657600" cy="502920"/>
+            <a:off x="594360" y="1463040"/>
+            <a:ext cx="457200" cy="365760"/>
           </a:xfrm>
           <a:prstGeom prst="rect">
             <a:avLst/>
@@ -8273,11 +8748,11 @@
           <a:bodyPr wrap="square" lIns="0" tIns="0" rIns="0" bIns="0" rtlCol="0" anchor="t"/>
           <a:lstStyle/>
           <a:p>
-            <a:pPr indent="0" marL="0">
+            <a:pPr algn="ctr" indent="0" marL="0">
               <a:buNone/>
             </a:pPr>
             <a:r>
-              <a:rPr lang="en-US" sz="1300" dirty="0">
+              <a:rPr lang="en-US" sz="1800" b="1" dirty="0">
                 <a:solidFill>
                   <a:schemeClr val="tx1"/>
                 </a:solidFill>
@@ -8285,9 +8760,9 @@
                 <a:ea typeface="Calibri" pitchFamily="34" charset="-122"/>
                 <a:cs typeface="Calibri" pitchFamily="34" charset="-120"/>
               </a:rPr>
-              <a:t>memory for images, 137x smaller than our first version</a:t>
-            </a:r>
-            <a:endParaRPr lang="en-US" sz="1300" dirty="0"/>
+              <a:t>1</a:t>
+            </a:r>
+            <a:endParaRPr lang="en-US" sz="1800" dirty="0"/>
           </a:p>
         </p:txBody>
       </p:sp>
@@ -8299,8 +8774,8 @@
         </p:nvSpPr>
         <p:spPr>
           <a:xfrm>
-            <a:off x="640080" y="2450592"/>
-            <a:ext cx="3657600" cy="228600"/>
+            <a:off x="1234440" y="1353312"/>
+            <a:ext cx="1737360" cy="594360"/>
           </a:xfrm>
           <a:prstGeom prst="rect">
             <a:avLst/>
@@ -8309,41 +8784,80 @@
           <a:ln/>
         </p:spPr>
         <p:txBody>
-          <a:bodyPr wrap="square" lIns="0" tIns="0" rIns="0" bIns="0" rtlCol="0" anchor="t"/>
+          <a:bodyPr wrap="square" lIns="0" tIns="0" rIns="0" bIns="0" rtlCol="0" anchor="ctr"/>
           <a:lstStyle/>
           <a:p>
             <a:pPr indent="0" marL="0">
               <a:buNone/>
             </a:pPr>
             <a:r>
-              <a:rPr lang="en-US" sz="1100" b="1" dirty="0">
-                <a:solidFill>
-                  <a:schemeClr val="accent6"/>
+              <a:rPr lang="en-US" sz="1600" b="1" dirty="0">
+                <a:solidFill>
+                  <a:schemeClr val="tx1"/>
                 </a:solidFill>
                 <a:latin typeface="Calibri" pitchFamily="34" charset="0"/>
                 <a:ea typeface="Calibri" pitchFamily="34" charset="-122"/>
                 <a:cs typeface="Calibri" pitchFamily="34" charset="-120"/>
               </a:rPr>
-              <a:t>design fact</a:t>
-            </a:r>
-            <a:endParaRPr lang="en-US" sz="1100" dirty="0"/>
-          </a:p>
-        </p:txBody>
-      </p:sp>
-      <p:sp>
-        <p:nvSpPr>
-          <p:cNvPr id="7" name="card"/>
+              <a:t>Not the senses</a:t>
+            </a:r>
+            <a:endParaRPr lang="en-US" sz="1600" dirty="0"/>
+          </a:p>
+        </p:txBody>
+      </p:sp>
+      <p:sp>
+        <p:nvSpPr>
+          <p:cNvPr id="7" name="Text 5"/>
+          <p:cNvSpPr txBox="1"/>
+          <p:nvPr/>
+        </p:nvSpPr>
+        <p:spPr>
+          <a:xfrm>
+            <a:off x="2926080" y="1325880"/>
+            <a:ext cx="5577840" cy="658368"/>
+          </a:xfrm>
+          <a:prstGeom prst="rect">
+            <a:avLst/>
+          </a:prstGeom>
+          <a:noFill/>
+          <a:ln/>
+        </p:spPr>
+        <p:txBody>
+          <a:bodyPr wrap="square" lIns="0" tIns="0" rIns="0" bIns="0" rtlCol="0" anchor="ctr"/>
+          <a:lstStyle/>
+          <a:p>
+            <a:pPr indent="0" marL="0">
+              <a:buNone/>
+            </a:pPr>
+            <a:r>
+              <a:rPr lang="en-US" sz="1300" dirty="0">
+                <a:solidFill>
+                  <a:schemeClr val="tx1"/>
+                </a:solidFill>
+                <a:latin typeface="Calibri" pitchFamily="34" charset="0"/>
+                <a:ea typeface="Calibri" pitchFamily="34" charset="-122"/>
+                <a:cs typeface="Calibri" pitchFamily="34" charset="-120"/>
+              </a:rPr>
+              <a:t>A plain classifier trained on the chip's own code reaches 87.9% on clothing and 98.3% on digits. The code is good enough.</a:t>
+            </a:r>
+            <a:endParaRPr lang="en-US" sz="1300" dirty="0"/>
+          </a:p>
+        </p:txBody>
+      </p:sp>
+      <p:sp>
+        <p:nvSpPr>
+          <p:cNvPr id="8" name="card"/>
           <p:cNvSpPr/>
           <p:nvPr/>
         </p:nvSpPr>
         <p:spPr>
           <a:xfrm>
-            <a:off x="4663440" y="1188720"/>
-            <a:ext cx="4023360" cy="1554480"/>
+            <a:off x="457200" y="2148840"/>
+            <a:ext cx="8229600" cy="749808"/>
           </a:xfrm>
           <a:prstGeom prst="roundRect">
             <a:avLst>
-              <a:gd name="adj" fmla="val 5882"/>
+              <a:gd name="adj" fmla="val 12195"/>
             </a:avLst>
           </a:prstGeom>
           <a:solidFill>
@@ -8359,14 +8873,39 @@
       </p:sp>
       <p:sp>
         <p:nvSpPr>
-          <p:cNvPr id="8" name="Text 6"/>
+          <p:cNvPr id="9" name="marker"/>
+          <p:cNvSpPr/>
+          <p:nvPr/>
+        </p:nvSpPr>
+        <p:spPr>
+          <a:xfrm>
+            <a:off x="594360" y="2286000"/>
+            <a:ext cx="457200" cy="457200"/>
+          </a:xfrm>
+          <a:prstGeom prst="ellipse">
+            <a:avLst/>
+          </a:prstGeom>
+          <a:solidFill>
+            <a:schemeClr val="accent1"/>
+          </a:solidFill>
+          <a:ln w="12700">
+            <a:solidFill>
+              <a:schemeClr val="accent1"/>
+            </a:solidFill>
+            <a:prstDash val="solid"/>
+          </a:ln>
+        </p:spPr>
+      </p:sp>
+      <p:sp>
+        <p:nvSpPr>
+          <p:cNvPr id="10" name="Text 8"/>
           <p:cNvSpPr txBox="1"/>
           <p:nvPr/>
         </p:nvSpPr>
         <p:spPr>
           <a:xfrm>
-            <a:off x="4846320" y="1298448"/>
-            <a:ext cx="3657600" cy="640080"/>
+            <a:off x="594360" y="2331720"/>
+            <a:ext cx="457200" cy="365760"/>
           </a:xfrm>
           <a:prstGeom prst="rect">
             <a:avLst/>
@@ -8378,50 +8917,11 @@
           <a:bodyPr wrap="square" lIns="0" tIns="0" rIns="0" bIns="0" rtlCol="0" anchor="t"/>
           <a:lstStyle/>
           <a:p>
-            <a:pPr indent="0" marL="0">
+            <a:pPr algn="ctr" indent="0" marL="0">
               <a:buNone/>
             </a:pPr>
             <a:r>
-              <a:rPr lang="en-US" sz="3400" b="1" dirty="0">
-                <a:solidFill>
-                  <a:schemeClr val="accent2"/>
-                </a:solidFill>
-                <a:latin typeface="Cambria" pitchFamily="34" charset="0"/>
-                <a:ea typeface="Cambria" pitchFamily="34" charset="-122"/>
-                <a:cs typeface="Cambria" pitchFamily="34" charset="-120"/>
-              </a:rPr>
-              <a:t>0</a:t>
-            </a:r>
-            <a:endParaRPr lang="en-US" sz="3400" dirty="0"/>
-          </a:p>
-        </p:txBody>
-      </p:sp>
-      <p:sp>
-        <p:nvSpPr>
-          <p:cNvPr id="9" name="Text 7"/>
-          <p:cNvSpPr txBox="1"/>
-          <p:nvPr/>
-        </p:nvSpPr>
-        <p:spPr>
-          <a:xfrm>
-            <a:off x="4846320" y="1938528"/>
-            <a:ext cx="3657600" cy="502920"/>
-          </a:xfrm>
-          <a:prstGeom prst="rect">
-            <a:avLst/>
-          </a:prstGeom>
-          <a:noFill/>
-          <a:ln/>
-        </p:spPr>
-        <p:txBody>
-          <a:bodyPr wrap="square" lIns="0" tIns="0" rIns="0" bIns="0" rtlCol="0" anchor="t"/>
-          <a:lstStyle/>
-          <a:p>
-            <a:pPr indent="0" marL="0">
-              <a:buNone/>
-            </a:pPr>
-            <a:r>
-              <a:rPr lang="en-US" sz="1300" dirty="0">
+              <a:rPr lang="en-US" sz="1800" b="1" dirty="0">
                 <a:solidFill>
                   <a:schemeClr val="tx1"/>
                 </a:solidFill>
@@ -8429,22 +8929,22 @@
                 <a:ea typeface="Calibri" pitchFamily="34" charset="-122"/>
                 <a:cs typeface="Calibri" pitchFamily="34" charset="-120"/>
               </a:rPr>
-              <a:t>hardware multipliers used on the $25 Tang Nano 20K (89% logic, 46/46 block RAM)</a:t>
-            </a:r>
-            <a:endParaRPr lang="en-US" sz="1300" dirty="0"/>
-          </a:p>
-        </p:txBody>
-      </p:sp>
-      <p:sp>
-        <p:nvSpPr>
-          <p:cNvPr id="10" name="Text 8"/>
+              <a:t>2</a:t>
+            </a:r>
+            <a:endParaRPr lang="en-US" sz="1800" dirty="0"/>
+          </a:p>
+        </p:txBody>
+      </p:sp>
+      <p:sp>
+        <p:nvSpPr>
+          <p:cNvPr id="11" name="Text 9"/>
           <p:cNvSpPr txBox="1"/>
           <p:nvPr/>
         </p:nvSpPr>
         <p:spPr>
           <a:xfrm>
-            <a:off x="4846320" y="2450592"/>
-            <a:ext cx="3657600" cy="228600"/>
+            <a:off x="1234440" y="2221992"/>
+            <a:ext cx="1737360" cy="594360"/>
           </a:xfrm>
           <a:prstGeom prst="rect">
             <a:avLst/>
@@ -8453,41 +8953,80 @@
           <a:ln/>
         </p:spPr>
         <p:txBody>
-          <a:bodyPr wrap="square" lIns="0" tIns="0" rIns="0" bIns="0" rtlCol="0" anchor="t"/>
+          <a:bodyPr wrap="square" lIns="0" tIns="0" rIns="0" bIns="0" rtlCol="0" anchor="ctr"/>
           <a:lstStyle/>
           <a:p>
             <a:pPr indent="0" marL="0">
               <a:buNone/>
             </a:pPr>
             <a:r>
-              <a:rPr lang="en-US" sz="1100" b="1" dirty="0">
-                <a:solidFill>
-                  <a:schemeClr val="accent6"/>
+              <a:rPr lang="en-US" sz="1600" b="1" dirty="0">
+                <a:solidFill>
+                  <a:schemeClr val="tx1"/>
                 </a:solidFill>
                 <a:latin typeface="Calibri" pitchFamily="34" charset="0"/>
                 <a:ea typeface="Calibri" pitchFamily="34" charset="-122"/>
                 <a:cs typeface="Calibri" pitchFamily="34" charset="-120"/>
               </a:rPr>
-              <a:t>SIMULATED, place and route</a:t>
-            </a:r>
-            <a:endParaRPr lang="en-US" sz="1100" dirty="0"/>
-          </a:p>
-        </p:txBody>
-      </p:sp>
-      <p:sp>
-        <p:nvSpPr>
-          <p:cNvPr id="11" name="card"/>
+              <a:t>The readout</a:t>
+            </a:r>
+            <a:endParaRPr lang="en-US" sz="1600" dirty="0"/>
+          </a:p>
+        </p:txBody>
+      </p:sp>
+      <p:sp>
+        <p:nvSpPr>
+          <p:cNvPr id="12" name="Text 10"/>
+          <p:cNvSpPr txBox="1"/>
+          <p:nvPr/>
+        </p:nvSpPr>
+        <p:spPr>
+          <a:xfrm>
+            <a:off x="2926080" y="2194560"/>
+            <a:ext cx="5577840" cy="658368"/>
+          </a:xfrm>
+          <a:prstGeom prst="rect">
+            <a:avLst/>
+          </a:prstGeom>
+          <a:noFill/>
+          <a:ln/>
+        </p:spPr>
+        <p:txBody>
+          <a:bodyPr wrap="square" lIns="0" tIns="0" rIns="0" bIns="0" rtlCol="0" anchor="ctr"/>
+          <a:lstStyle/>
+          <a:p>
+            <a:pPr indent="0" marL="0">
+              <a:buNone/>
+            </a:pPr>
+            <a:r>
+              <a:rPr lang="en-US" sz="1300" dirty="0">
+                <a:solidFill>
+                  <a:schemeClr val="tx1"/>
+                </a:solidFill>
+                <a:latin typeface="Calibri" pitchFamily="34" charset="0"/>
+                <a:ea typeface="Calibri" pitchFamily="34" charset="-122"/>
+                <a:cs typeface="Calibri" pitchFamily="34" charset="-120"/>
+              </a:rPr>
+              <a:t>The chip learns its table online in one pass with 5-bit entries, which loses 3 to 4 points.</a:t>
+            </a:r>
+            <a:endParaRPr lang="en-US" sz="1300" dirty="0"/>
+          </a:p>
+        </p:txBody>
+      </p:sp>
+      <p:sp>
+        <p:nvSpPr>
+          <p:cNvPr id="13" name="card"/>
           <p:cNvSpPr/>
           <p:nvPr/>
         </p:nvSpPr>
         <p:spPr>
           <a:xfrm>
-            <a:off x="457200" y="2880360"/>
-            <a:ext cx="4023360" cy="1554480"/>
+            <a:off x="457200" y="3017520"/>
+            <a:ext cx="8229600" cy="749808"/>
           </a:xfrm>
           <a:prstGeom prst="roundRect">
             <a:avLst>
-              <a:gd name="adj" fmla="val 5882"/>
+              <a:gd name="adj" fmla="val 12195"/>
             </a:avLst>
           </a:prstGeom>
           <a:solidFill>
@@ -8503,14 +9042,39 @@
       </p:sp>
       <p:sp>
         <p:nvSpPr>
-          <p:cNvPr id="12" name="Text 10"/>
+          <p:cNvPr id="14" name="marker"/>
+          <p:cNvSpPr/>
+          <p:nvPr/>
+        </p:nvSpPr>
+        <p:spPr>
+          <a:xfrm>
+            <a:off x="594360" y="3154680"/>
+            <a:ext cx="457200" cy="457200"/>
+          </a:xfrm>
+          <a:prstGeom prst="ellipse">
+            <a:avLst/>
+          </a:prstGeom>
+          <a:solidFill>
+            <a:schemeClr val="accent3"/>
+          </a:solidFill>
+          <a:ln w="12700">
+            <a:solidFill>
+              <a:schemeClr val="accent3"/>
+            </a:solidFill>
+            <a:prstDash val="solid"/>
+          </a:ln>
+        </p:spPr>
+      </p:sp>
+      <p:sp>
+        <p:nvSpPr>
+          <p:cNvPr id="15" name="Text 13"/>
           <p:cNvSpPr txBox="1"/>
           <p:nvPr/>
         </p:nvSpPr>
         <p:spPr>
           <a:xfrm>
-            <a:off x="640080" y="2990088"/>
-            <a:ext cx="3657600" cy="640080"/>
+            <a:off x="594360" y="3200400"/>
+            <a:ext cx="457200" cy="365760"/>
           </a:xfrm>
           <a:prstGeom prst="rect">
             <a:avLst/>
@@ -8522,50 +9086,11 @@
           <a:bodyPr wrap="square" lIns="0" tIns="0" rIns="0" bIns="0" rtlCol="0" anchor="t"/>
           <a:lstStyle/>
           <a:p>
-            <a:pPr indent="0" marL="0">
+            <a:pPr algn="ctr" indent="0" marL="0">
               <a:buNone/>
             </a:pPr>
             <a:r>
-              <a:rPr lang="en-US" sz="3400" b="1" dirty="0">
-                <a:solidFill>
-                  <a:schemeClr val="accent2"/>
-                </a:solidFill>
-                <a:latin typeface="Cambria" pitchFamily="34" charset="0"/>
-                <a:ea typeface="Cambria" pitchFamily="34" charset="-122"/>
-                <a:cs typeface="Cambria" pitchFamily="34" charset="-120"/>
-              </a:rPr>
-              <a:t>~74x</a:t>
-            </a:r>
-            <a:endParaRPr lang="en-US" sz="3400" dirty="0"/>
-          </a:p>
-        </p:txBody>
-      </p:sp>
-      <p:sp>
-        <p:nvSpPr>
-          <p:cNvPr id="13" name="Text 11"/>
-          <p:cNvSpPr txBox="1"/>
-          <p:nvPr/>
-        </p:nvSpPr>
-        <p:spPr>
-          <a:xfrm>
-            <a:off x="640080" y="3630168"/>
-            <a:ext cx="3657600" cy="502920"/>
-          </a:xfrm>
-          <a:prstGeom prst="rect">
-            <a:avLst/>
-          </a:prstGeom>
-          <a:noFill/>
-          <a:ln/>
-        </p:spPr>
-        <p:txBody>
-          <a:bodyPr wrap="square" lIns="0" tIns="0" rIns="0" bIns="0" rtlCol="0" anchor="t"/>
-          <a:lstStyle/>
-          <a:p>
-            <a:pPr indent="0" marL="0">
-              <a:buNone/>
-            </a:pPr>
-            <a:r>
-              <a:rPr lang="en-US" sz="1300" dirty="0">
+              <a:rPr lang="en-US" sz="1800" b="1" dirty="0">
                 <a:solidFill>
                   <a:schemeClr val="tx1"/>
                 </a:solidFill>
@@ -8573,22 +9098,22 @@
                 <a:ea typeface="Calibri" pitchFamily="34" charset="-122"/>
                 <a:cs typeface="Calibri" pitchFamily="34" charset="-120"/>
               </a:rPr>
-              <a:t>less energy per decision than an 8-bit network, counting the operations needed (9.4 nJ vs 696 nJ)</a:t>
-            </a:r>
-            <a:endParaRPr lang="en-US" sz="1300" dirty="0"/>
-          </a:p>
-        </p:txBody>
-      </p:sp>
-      <p:sp>
-        <p:nvSpPr>
-          <p:cNvPr id="14" name="Text 12"/>
+              <a:t>3</a:t>
+            </a:r>
+            <a:endParaRPr lang="en-US" sz="1800" dirty="0"/>
+          </a:p>
+        </p:txBody>
+      </p:sp>
+      <p:sp>
+        <p:nvSpPr>
+          <p:cNvPr id="16" name="Text 14"/>
           <p:cNvSpPr txBox="1"/>
           <p:nvPr/>
         </p:nvSpPr>
         <p:spPr>
           <a:xfrm>
-            <a:off x="640080" y="4142232"/>
-            <a:ext cx="3657600" cy="228600"/>
+            <a:off x="1234440" y="3090672"/>
+            <a:ext cx="1737360" cy="594360"/>
           </a:xfrm>
           <a:prstGeom prst="rect">
             <a:avLst/>
@@ -8597,41 +9122,80 @@
           <a:ln/>
         </p:spPr>
         <p:txBody>
-          <a:bodyPr wrap="square" lIns="0" tIns="0" rIns="0" bIns="0" rtlCol="0" anchor="t"/>
+          <a:bodyPr wrap="square" lIns="0" tIns="0" rIns="0" bIns="0" rtlCol="0" anchor="ctr"/>
           <a:lstStyle/>
           <a:p>
             <a:pPr indent="0" marL="0">
               <a:buNone/>
             </a:pPr>
             <a:r>
-              <a:rPr lang="en-US" sz="1100" b="1" dirty="0">
-                <a:solidFill>
-                  <a:schemeClr val="accent6"/>
+              <a:rPr lang="en-US" sz="1600" b="1" dirty="0">
+                <a:solidFill>
+                  <a:schemeClr val="tx1"/>
                 </a:solidFill>
                 <a:latin typeface="Calibri" pitchFamily="34" charset="0"/>
                 <a:ea typeface="Calibri" pitchFamily="34" charset="-122"/>
                 <a:cs typeface="Calibri" pitchFamily="34" charset="-120"/>
               </a:rPr>
-              <a:t>ESTIMATED</a:t>
-            </a:r>
-            <a:endParaRPr lang="en-US" sz="1100" dirty="0"/>
-          </a:p>
-        </p:txBody>
-      </p:sp>
-      <p:sp>
-        <p:nvSpPr>
-          <p:cNvPr id="15" name="card"/>
+              <a:t>The fix</a:t>
+            </a:r>
+            <a:endParaRPr lang="en-US" sz="1600" dirty="0"/>
+          </a:p>
+        </p:txBody>
+      </p:sp>
+      <p:sp>
+        <p:nvSpPr>
+          <p:cNvPr id="17" name="Text 15"/>
+          <p:cNvSpPr txBox="1"/>
+          <p:nvPr/>
+        </p:nvSpPr>
+        <p:spPr>
+          <a:xfrm>
+            <a:off x="2926080" y="3063240"/>
+            <a:ext cx="5577840" cy="658368"/>
+          </a:xfrm>
+          <a:prstGeom prst="rect">
+            <a:avLst/>
+          </a:prstGeom>
+          <a:noFill/>
+          <a:ln/>
+        </p:spPr>
+        <p:txBody>
+          <a:bodyPr wrap="square" lIns="0" tIns="0" rIns="0" bIns="0" rtlCol="0" anchor="ctr"/>
+          <a:lstStyle/>
+          <a:p>
+            <a:pPr indent="0" marL="0">
+              <a:buNone/>
+            </a:pPr>
+            <a:r>
+              <a:rPr lang="en-US" sz="1300" dirty="0">
+                <a:solidFill>
+                  <a:schemeClr val="tx1"/>
+                </a:solidFill>
+                <a:latin typeface="Calibri" pitchFamily="34" charset="0"/>
+                <a:ea typeface="Calibri" pitchFamily="34" charset="-122"/>
+                <a:cs typeface="Calibri" pitchFamily="34" charset="-120"/>
+              </a:rPr>
+              <a:t>A slow second table averages the fast one: clothing 83.4 to 86.9, words 83.1 to 85.7, digits 97.0 to 97.6. Shifts and adds only; bit-exact in RTL; an ASIC option.</a:t>
+            </a:r>
+            <a:endParaRPr lang="en-US" sz="1300" dirty="0"/>
+          </a:p>
+        </p:txBody>
+      </p:sp>
+      <p:sp>
+        <p:nvSpPr>
+          <p:cNvPr id="18" name="card"/>
           <p:cNvSpPr/>
           <p:nvPr/>
         </p:nvSpPr>
         <p:spPr>
           <a:xfrm>
-            <a:off x="4663440" y="2880360"/>
-            <a:ext cx="4023360" cy="1554480"/>
+            <a:off x="457200" y="3886200"/>
+            <a:ext cx="8229600" cy="749808"/>
           </a:xfrm>
           <a:prstGeom prst="roundRect">
             <a:avLst>
-              <a:gd name="adj" fmla="val 5882"/>
+              <a:gd name="adj" fmla="val 12195"/>
             </a:avLst>
           </a:prstGeom>
           <a:solidFill>
@@ -8647,14 +9211,39 @@
       </p:sp>
       <p:sp>
         <p:nvSpPr>
-          <p:cNvPr id="16" name="Text 14"/>
+          <p:cNvPr id="19" name="marker"/>
+          <p:cNvSpPr/>
+          <p:nvPr/>
+        </p:nvSpPr>
+        <p:spPr>
+          <a:xfrm>
+            <a:off x="594360" y="4023360"/>
+            <a:ext cx="457200" cy="457200"/>
+          </a:xfrm>
+          <a:prstGeom prst="ellipse">
+            <a:avLst/>
+          </a:prstGeom>
+          <a:solidFill>
+            <a:schemeClr val="accent1"/>
+          </a:solidFill>
+          <a:ln w="12700">
+            <a:solidFill>
+              <a:schemeClr val="accent1"/>
+            </a:solidFill>
+            <a:prstDash val="solid"/>
+          </a:ln>
+        </p:spPr>
+      </p:sp>
+      <p:sp>
+        <p:nvSpPr>
+          <p:cNvPr id="20" name="Text 18"/>
           <p:cNvSpPr txBox="1"/>
           <p:nvPr/>
         </p:nvSpPr>
         <p:spPr>
           <a:xfrm>
-            <a:off x="4846320" y="2990088"/>
-            <a:ext cx="3657600" cy="640080"/>
+            <a:off x="594360" y="4069080"/>
+            <a:ext cx="457200" cy="365760"/>
           </a:xfrm>
           <a:prstGeom prst="rect">
             <a:avLst/>
@@ -8666,50 +9255,11 @@
           <a:bodyPr wrap="square" lIns="0" tIns="0" rIns="0" bIns="0" rtlCol="0" anchor="t"/>
           <a:lstStyle/>
           <a:p>
-            <a:pPr indent="0" marL="0">
+            <a:pPr algn="ctr" indent="0" marL="0">
               <a:buNone/>
             </a:pPr>
             <a:r>
-              <a:rPr lang="en-US" sz="3400" b="1" dirty="0">
-                <a:solidFill>
-                  <a:schemeClr val="accent2"/>
-                </a:solidFill>
-                <a:latin typeface="Cambria" pitchFamily="34" charset="0"/>
-                <a:ea typeface="Cambria" pitchFamily="34" charset="-122"/>
-                <a:cs typeface="Cambria" pitchFamily="34" charset="-120"/>
-              </a:rPr>
-              <a:t>&lt; 1 mm2</a:t>
-            </a:r>
-            <a:endParaRPr lang="en-US" sz="3400" dirty="0"/>
-          </a:p>
-        </p:txBody>
-      </p:sp>
-      <p:sp>
-        <p:nvSpPr>
-          <p:cNvPr id="17" name="Text 15"/>
-          <p:cNvSpPr txBox="1"/>
-          <p:nvPr/>
-        </p:nvSpPr>
-        <p:spPr>
-          <a:xfrm>
-            <a:off x="4846320" y="3630168"/>
-            <a:ext cx="3657600" cy="502920"/>
-          </a:xfrm>
-          <a:prstGeom prst="rect">
-            <a:avLst/>
-          </a:prstGeom>
-          <a:noFill/>
-          <a:ln/>
-        </p:spPr>
-        <p:txBody>
-          <a:bodyPr wrap="square" lIns="0" tIns="0" rIns="0" bIns="0" rtlCol="0" anchor="t"/>
-          <a:lstStyle/>
-          <a:p>
-            <a:pPr indent="0" marL="0">
-              <a:buNone/>
-            </a:pPr>
-            <a:r>
-              <a:rPr lang="en-US" sz="1300" dirty="0">
+              <a:rPr lang="en-US" sz="1800" b="1" dirty="0">
                 <a:solidFill>
                   <a:schemeClr val="tx1"/>
                 </a:solidFill>
@@ -8717,22 +9267,22 @@
                 <a:ea typeface="Calibri" pitchFamily="34" charset="-122"/>
                 <a:cs typeface="Calibri" pitchFamily="34" charset="-120"/>
               </a:rPr>
-              <a:t>SKY130 logic area; 18.8 mm2 with open SRAM macros</a:t>
-            </a:r>
-            <a:endParaRPr lang="en-US" sz="1300" dirty="0"/>
-          </a:p>
-        </p:txBody>
-      </p:sp>
-      <p:sp>
-        <p:nvSpPr>
-          <p:cNvPr id="18" name="Text 16"/>
+              <a:t>4</a:t>
+            </a:r>
+            <a:endParaRPr lang="en-US" sz="1800" dirty="0"/>
+          </a:p>
+        </p:txBody>
+      </p:sp>
+      <p:sp>
+        <p:nvSpPr>
+          <p:cNvPr id="21" name="Text 19"/>
           <p:cNvSpPr txBox="1"/>
           <p:nvPr/>
         </p:nvSpPr>
         <p:spPr>
           <a:xfrm>
-            <a:off x="4846320" y="4142232"/>
-            <a:ext cx="3657600" cy="228600"/>
+            <a:off x="1234440" y="3959352"/>
+            <a:ext cx="1737360" cy="594360"/>
           </a:xfrm>
           <a:prstGeom prst="rect">
             <a:avLst/>
@@ -8741,37 +9291,37 @@
           <a:ln/>
         </p:spPr>
         <p:txBody>
-          <a:bodyPr wrap="square" lIns="0" tIns="0" rIns="0" bIns="0" rtlCol="0" anchor="t"/>
+          <a:bodyPr wrap="square" lIns="0" tIns="0" rIns="0" bIns="0" rtlCol="0" anchor="ctr"/>
           <a:lstStyle/>
           <a:p>
             <a:pPr indent="0" marL="0">
               <a:buNone/>
             </a:pPr>
             <a:r>
-              <a:rPr lang="en-US" sz="1100" b="1" dirty="0">
-                <a:solidFill>
-                  <a:schemeClr val="accent6"/>
+              <a:rPr lang="en-US" sz="1600" b="1" dirty="0">
+                <a:solidFill>
+                  <a:schemeClr val="tx1"/>
                 </a:solidFill>
                 <a:latin typeface="Calibri" pitchFamily="34" charset="0"/>
                 <a:ea typeface="Calibri" pitchFamily="34" charset="-122"/>
                 <a:cs typeface="Calibri" pitchFamily="34" charset="-120"/>
               </a:rPr>
-              <a:t>ESTIMATED</a:t>
-            </a:r>
-            <a:endParaRPr lang="en-US" sz="1100" dirty="0"/>
-          </a:p>
-        </p:txBody>
-      </p:sp>
-      <p:sp>
-        <p:nvSpPr>
-          <p:cNvPr id="19" name="Text 17"/>
+              <a:t>Next gain</a:t>
+            </a:r>
+            <a:endParaRPr lang="en-US" sz="1600" dirty="0"/>
+          </a:p>
+        </p:txBody>
+      </p:sp>
+      <p:sp>
+        <p:nvSpPr>
+          <p:cNvPr id="22" name="Text 20"/>
           <p:cNvSpPr txBox="1"/>
           <p:nvPr/>
         </p:nvSpPr>
         <p:spPr>
           <a:xfrm>
-            <a:off x="457200" y="4526280"/>
-            <a:ext cx="7955280" cy="411480"/>
+            <a:off x="2926080" y="3931920"/>
+            <a:ext cx="5577840" cy="658368"/>
           </a:xfrm>
           <a:prstGeom prst="rect">
             <a:avLst/>
@@ -8780,24 +9330,24 @@
           <a:ln/>
         </p:spPr>
         <p:txBody>
-          <a:bodyPr wrap="square" lIns="0" tIns="0" rIns="0" bIns="0" rtlCol="0" anchor="t"/>
+          <a:bodyPr wrap="square" lIns="0" tIns="0" rIns="0" bIns="0" rtlCol="0" anchor="ctr"/>
           <a:lstStyle/>
           <a:p>
             <a:pPr indent="0" marL="0">
               <a:buNone/>
             </a:pPr>
             <a:r>
-              <a:rPr lang="en-US" sz="1200" dirty="0">
-                <a:solidFill>
-                  <a:schemeClr val="accent4"/>
+              <a:rPr lang="en-US" sz="1300" dirty="0">
+                <a:solidFill>
+                  <a:schemeClr val="tx1"/>
                 </a:solidFill>
                 <a:latin typeface="Calibri" pitchFamily="34" charset="0"/>
                 <a:ea typeface="Calibri" pitchFamily="34" charset="-122"/>
                 <a:cs typeface="Calibri" pitchFamily="34" charset="-120"/>
               </a:rPr>
-              <a:t>Say it carefully: the 74x is per operation needed. The SKY130 layout estimate is 0.18 to 0.26 uJ per decision, still 20 to 28x above the operation count.</a:t>
-            </a:r>
-            <a:endParaRPr lang="en-US" sz="1200" dirty="0"/>
+              <a:t>A finer detector grid for images: clothing 88.0, digits 98.3 all at once. It makes staged digits worse (93.2%), so it is an option.</a:t>
+            </a:r>
+            <a:endParaRPr lang="en-US" sz="1300" dirty="0"/>
           </a:p>
         </p:txBody>
       </p:sp>
@@ -8906,7 +9456,7 @@
                 <a:ea typeface="Cambria" pitchFamily="34" charset="-122"/>
                 <a:cs typeface="Cambria" pitchFamily="34" charset="-120"/>
               </a:rPr>
-              <a:t>Verified bit for bit, and laid out</a:t>
+              <a:t>Small, cheap, and no multiplier</a:t>
             </a:r>
             <a:endParaRPr lang="en-US" sz="3000" dirty="0"/>
           </a:p>
@@ -8920,12 +9470,12 @@
         </p:nvSpPr>
         <p:spPr>
           <a:xfrm>
-            <a:off x="457200" y="1280160"/>
-            <a:ext cx="4023360" cy="3200400"/>
+            <a:off x="457200" y="1188720"/>
+            <a:ext cx="4023360" cy="1554480"/>
           </a:xfrm>
           <a:prstGeom prst="roundRect">
             <a:avLst>
-              <a:gd name="adj" fmla="val 2857"/>
+              <a:gd name="adj" fmla="val 5882"/>
             </a:avLst>
           </a:prstGeom>
           <a:solidFill>
@@ -8947,8 +9497,8 @@
         </p:nvSpPr>
         <p:spPr>
           <a:xfrm>
-            <a:off x="640080" y="1417320"/>
-            <a:ext cx="3657600" cy="914400"/>
+            <a:off x="640080" y="1298448"/>
+            <a:ext cx="3657600" cy="640080"/>
           </a:xfrm>
           <a:prstGeom prst="rect">
             <a:avLst/>
@@ -8964,17 +9514,17 @@
               <a:buNone/>
             </a:pPr>
             <a:r>
-              <a:rPr lang="en-US" sz="5400" b="1" dirty="0">
-                <a:solidFill>
-                  <a:schemeClr val="accent3"/>
+              <a:rPr lang="en-US" sz="3400" b="1" dirty="0">
+                <a:solidFill>
+                  <a:schemeClr val="accent2"/>
                 </a:solidFill>
                 <a:latin typeface="Cambria" pitchFamily="34" charset="0"/>
                 <a:ea typeface="Cambria" pitchFamily="34" charset="-122"/>
                 <a:cs typeface="Cambria" pitchFamily="34" charset="-120"/>
               </a:rPr>
-              <a:t>18 / 18</a:t>
-            </a:r>
-            <a:endParaRPr lang="en-US" sz="5400" dirty="0"/>
+              <a:t>84 KB</a:t>
+            </a:r>
+            <a:endParaRPr lang="en-US" sz="3400" dirty="0"/>
           </a:p>
         </p:txBody>
       </p:sp>
@@ -8986,8 +9536,8 @@
         </p:nvSpPr>
         <p:spPr>
           <a:xfrm>
-            <a:off x="640080" y="2514600"/>
-            <a:ext cx="3657600" cy="1645920"/>
+            <a:off x="640080" y="1938528"/>
+            <a:ext cx="3657600" cy="502920"/>
           </a:xfrm>
           <a:prstGeom prst="rect">
             <a:avLst/>
@@ -9003,7 +9553,7 @@
               <a:buNone/>
             </a:pPr>
             <a:r>
-              <a:rPr lang="en-US" sz="1400" dirty="0">
+              <a:rPr lang="en-US" sz="1300" dirty="0">
                 <a:solidFill>
                   <a:schemeClr val="tx1"/>
                 </a:solidFill>
@@ -9011,9 +9561,9 @@
                 <a:ea typeface="Calibri" pitchFamily="34" charset="-122"/>
                 <a:cs typeface="Calibri" pitchFamily="34" charset="-120"/>
               </a:rPr>
-              <a:t>RTL checks pass with 0 mismatches against the integer model: core, IMPRINT, encoder, learning detectors, cochlea, whole sound chain, board top, host schedule.</a:t>
-            </a:r>
-            <a:endParaRPr lang="en-US" sz="1400" dirty="0"/>
+              <a:t>memory for images, 137x smaller than our first version</a:t>
+            </a:r>
+            <a:endParaRPr lang="en-US" sz="1300" dirty="0"/>
           </a:p>
         </p:txBody>
       </p:sp>
@@ -9025,8 +9575,8 @@
         </p:nvSpPr>
         <p:spPr>
           <a:xfrm>
-            <a:off x="640080" y="4069080"/>
-            <a:ext cx="3657600" cy="365760"/>
+            <a:off x="640080" y="2450592"/>
+            <a:ext cx="3657600" cy="228600"/>
           </a:xfrm>
           <a:prstGeom prst="rect">
             <a:avLst/>
@@ -9050,7 +9600,7 @@
                 <a:ea typeface="Calibri" pitchFamily="34" charset="-122"/>
                 <a:cs typeface="Calibri" pitchFamily="34" charset="-120"/>
               </a:rPr>
-              <a:t>SIMULATED (RTL simulation)</a:t>
+              <a:t>design fact</a:t>
             </a:r>
             <a:endParaRPr lang="en-US" sz="1100" dirty="0"/>
           </a:p>
@@ -9064,12 +9614,12 @@
         </p:nvSpPr>
         <p:spPr>
           <a:xfrm>
-            <a:off x="4663440" y="1280160"/>
-            <a:ext cx="4023360" cy="3200400"/>
+            <a:off x="4663440" y="1188720"/>
+            <a:ext cx="4023360" cy="1554480"/>
           </a:xfrm>
           <a:prstGeom prst="roundRect">
             <a:avLst>
-              <a:gd name="adj" fmla="val 2857"/>
+              <a:gd name="adj" fmla="val 5882"/>
             </a:avLst>
           </a:prstGeom>
           <a:solidFill>
@@ -9091,8 +9641,8 @@
         </p:nvSpPr>
         <p:spPr>
           <a:xfrm>
-            <a:off x="4846320" y="1417320"/>
-            <a:ext cx="3657600" cy="914400"/>
+            <a:off x="4846320" y="1298448"/>
+            <a:ext cx="3657600" cy="640080"/>
           </a:xfrm>
           <a:prstGeom prst="rect">
             <a:avLst/>
@@ -9108,17 +9658,17 @@
               <a:buNone/>
             </a:pPr>
             <a:r>
-              <a:rPr lang="en-US" sz="5400" b="1" dirty="0">
-                <a:solidFill>
-                  <a:schemeClr val="accent1"/>
+              <a:rPr lang="en-US" sz="3400" b="1" dirty="0">
+                <a:solidFill>
+                  <a:schemeClr val="accent2"/>
                 </a:solidFill>
                 <a:latin typeface="Cambria" pitchFamily="34" charset="0"/>
                 <a:ea typeface="Cambria" pitchFamily="34" charset="-122"/>
                 <a:cs typeface="Cambria" pitchFamily="34" charset="-120"/>
               </a:rPr>
-              <a:t>1</a:t>
-            </a:r>
-            <a:endParaRPr lang="en-US" sz="5400" dirty="0"/>
+              <a:t>0</a:t>
+            </a:r>
+            <a:endParaRPr lang="en-US" sz="3400" dirty="0"/>
           </a:p>
         </p:txBody>
       </p:sp>
@@ -9130,8 +9680,8 @@
         </p:nvSpPr>
         <p:spPr>
           <a:xfrm>
-            <a:off x="4846320" y="2514600"/>
-            <a:ext cx="3657600" cy="1645920"/>
+            <a:off x="4846320" y="1938528"/>
+            <a:ext cx="3657600" cy="502920"/>
           </a:xfrm>
           <a:prstGeom prst="rect">
             <a:avLst/>
@@ -9147,7 +9697,7 @@
               <a:buNone/>
             </a:pPr>
             <a:r>
-              <a:rPr lang="en-US" sz="1400" dirty="0">
+              <a:rPr lang="en-US" sz="1300" dirty="0">
                 <a:solidFill>
                   <a:schemeClr val="tx1"/>
                 </a:solidFill>
@@ -9155,9 +9705,9 @@
                 <a:ea typeface="Calibri" pitchFamily="34" charset="-122"/>
                 <a:cs typeface="Calibri" pitchFamily="34" charset="-120"/>
               </a:rPr>
-              <a:t>violation left in detailed routing of the SKY130 layout (from 174,309 on the first pass). The last one is a power-versus-signal short at a memory macro edge.</a:t>
-            </a:r>
-            <a:endParaRPr lang="en-US" sz="1400" dirty="0"/>
+              <a:t>hardware multipliers used on the $25 Tang Nano 20K (89% logic, 46/46 block RAM)</a:t>
+            </a:r>
+            <a:endParaRPr lang="en-US" sz="1300" dirty="0"/>
           </a:p>
         </p:txBody>
       </p:sp>
@@ -9169,8 +9719,8 @@
         </p:nvSpPr>
         <p:spPr>
           <a:xfrm>
-            <a:off x="4846320" y="4069080"/>
-            <a:ext cx="3657600" cy="365760"/>
+            <a:off x="4846320" y="2450592"/>
+            <a:ext cx="3657600" cy="228600"/>
           </a:xfrm>
           <a:prstGeom prst="rect">
             <a:avLst/>
@@ -9194,9 +9744,336 @@
                 <a:ea typeface="Calibri" pitchFamily="34" charset="-122"/>
                 <a:cs typeface="Calibri" pitchFamily="34" charset="-120"/>
               </a:rPr>
-              <a:t>ESTIMATED (open-source flow, no sign-off)</a:t>
+              <a:t>SIMULATED, place and route</a:t>
             </a:r>
             <a:endParaRPr lang="en-US" sz="1100" dirty="0"/>
+          </a:p>
+        </p:txBody>
+      </p:sp>
+      <p:sp>
+        <p:nvSpPr>
+          <p:cNvPr id="11" name="card"/>
+          <p:cNvSpPr/>
+          <p:nvPr/>
+        </p:nvSpPr>
+        <p:spPr>
+          <a:xfrm>
+            <a:off x="457200" y="2880360"/>
+            <a:ext cx="4023360" cy="1554480"/>
+          </a:xfrm>
+          <a:prstGeom prst="roundRect">
+            <a:avLst>
+              <a:gd name="adj" fmla="val 5882"/>
+            </a:avLst>
+          </a:prstGeom>
+          <a:solidFill>
+            <a:schemeClr val="bg2"/>
+          </a:solidFill>
+          <a:ln w="12700">
+            <a:solidFill>
+              <a:schemeClr val="bg2"/>
+            </a:solidFill>
+            <a:prstDash val="solid"/>
+          </a:ln>
+        </p:spPr>
+      </p:sp>
+      <p:sp>
+        <p:nvSpPr>
+          <p:cNvPr id="12" name="Text 10"/>
+          <p:cNvSpPr txBox="1"/>
+          <p:nvPr/>
+        </p:nvSpPr>
+        <p:spPr>
+          <a:xfrm>
+            <a:off x="640080" y="2990088"/>
+            <a:ext cx="3657600" cy="640080"/>
+          </a:xfrm>
+          <a:prstGeom prst="rect">
+            <a:avLst/>
+          </a:prstGeom>
+          <a:noFill/>
+          <a:ln/>
+        </p:spPr>
+        <p:txBody>
+          <a:bodyPr wrap="square" lIns="0" tIns="0" rIns="0" bIns="0" rtlCol="0" anchor="t"/>
+          <a:lstStyle/>
+          <a:p>
+            <a:pPr indent="0" marL="0">
+              <a:buNone/>
+            </a:pPr>
+            <a:r>
+              <a:rPr lang="en-US" sz="3400" b="1" dirty="0">
+                <a:solidFill>
+                  <a:schemeClr val="accent2"/>
+                </a:solidFill>
+                <a:latin typeface="Cambria" pitchFamily="34" charset="0"/>
+                <a:ea typeface="Cambria" pitchFamily="34" charset="-122"/>
+                <a:cs typeface="Cambria" pitchFamily="34" charset="-120"/>
+              </a:rPr>
+              <a:t>~74x</a:t>
+            </a:r>
+            <a:endParaRPr lang="en-US" sz="3400" dirty="0"/>
+          </a:p>
+        </p:txBody>
+      </p:sp>
+      <p:sp>
+        <p:nvSpPr>
+          <p:cNvPr id="13" name="Text 11"/>
+          <p:cNvSpPr txBox="1"/>
+          <p:nvPr/>
+        </p:nvSpPr>
+        <p:spPr>
+          <a:xfrm>
+            <a:off x="640080" y="3630168"/>
+            <a:ext cx="3657600" cy="502920"/>
+          </a:xfrm>
+          <a:prstGeom prst="rect">
+            <a:avLst/>
+          </a:prstGeom>
+          <a:noFill/>
+          <a:ln/>
+        </p:spPr>
+        <p:txBody>
+          <a:bodyPr wrap="square" lIns="0" tIns="0" rIns="0" bIns="0" rtlCol="0" anchor="t"/>
+          <a:lstStyle/>
+          <a:p>
+            <a:pPr indent="0" marL="0">
+              <a:buNone/>
+            </a:pPr>
+            <a:r>
+              <a:rPr lang="en-US" sz="1300" dirty="0">
+                <a:solidFill>
+                  <a:schemeClr val="tx1"/>
+                </a:solidFill>
+                <a:latin typeface="Calibri" pitchFamily="34" charset="0"/>
+                <a:ea typeface="Calibri" pitchFamily="34" charset="-122"/>
+                <a:cs typeface="Calibri" pitchFamily="34" charset="-120"/>
+              </a:rPr>
+              <a:t>less energy per decision than an 8-bit network, counting the operations needed (9.4 nJ vs 696 nJ)</a:t>
+            </a:r>
+            <a:endParaRPr lang="en-US" sz="1300" dirty="0"/>
+          </a:p>
+        </p:txBody>
+      </p:sp>
+      <p:sp>
+        <p:nvSpPr>
+          <p:cNvPr id="14" name="Text 12"/>
+          <p:cNvSpPr txBox="1"/>
+          <p:nvPr/>
+        </p:nvSpPr>
+        <p:spPr>
+          <a:xfrm>
+            <a:off x="640080" y="4142232"/>
+            <a:ext cx="3657600" cy="228600"/>
+          </a:xfrm>
+          <a:prstGeom prst="rect">
+            <a:avLst/>
+          </a:prstGeom>
+          <a:noFill/>
+          <a:ln/>
+        </p:spPr>
+        <p:txBody>
+          <a:bodyPr wrap="square" lIns="0" tIns="0" rIns="0" bIns="0" rtlCol="0" anchor="t"/>
+          <a:lstStyle/>
+          <a:p>
+            <a:pPr indent="0" marL="0">
+              <a:buNone/>
+            </a:pPr>
+            <a:r>
+              <a:rPr lang="en-US" sz="1100" b="1" dirty="0">
+                <a:solidFill>
+                  <a:schemeClr val="accent6"/>
+                </a:solidFill>
+                <a:latin typeface="Calibri" pitchFamily="34" charset="0"/>
+                <a:ea typeface="Calibri" pitchFamily="34" charset="-122"/>
+                <a:cs typeface="Calibri" pitchFamily="34" charset="-120"/>
+              </a:rPr>
+              <a:t>ESTIMATED</a:t>
+            </a:r>
+            <a:endParaRPr lang="en-US" sz="1100" dirty="0"/>
+          </a:p>
+        </p:txBody>
+      </p:sp>
+      <p:sp>
+        <p:nvSpPr>
+          <p:cNvPr id="15" name="card"/>
+          <p:cNvSpPr/>
+          <p:nvPr/>
+        </p:nvSpPr>
+        <p:spPr>
+          <a:xfrm>
+            <a:off x="4663440" y="2880360"/>
+            <a:ext cx="4023360" cy="1554480"/>
+          </a:xfrm>
+          <a:prstGeom prst="roundRect">
+            <a:avLst>
+              <a:gd name="adj" fmla="val 5882"/>
+            </a:avLst>
+          </a:prstGeom>
+          <a:solidFill>
+            <a:schemeClr val="bg2"/>
+          </a:solidFill>
+          <a:ln w="12700">
+            <a:solidFill>
+              <a:schemeClr val="bg2"/>
+            </a:solidFill>
+            <a:prstDash val="solid"/>
+          </a:ln>
+        </p:spPr>
+      </p:sp>
+      <p:sp>
+        <p:nvSpPr>
+          <p:cNvPr id="16" name="Text 14"/>
+          <p:cNvSpPr txBox="1"/>
+          <p:nvPr/>
+        </p:nvSpPr>
+        <p:spPr>
+          <a:xfrm>
+            <a:off x="4846320" y="2990088"/>
+            <a:ext cx="3657600" cy="640080"/>
+          </a:xfrm>
+          <a:prstGeom prst="rect">
+            <a:avLst/>
+          </a:prstGeom>
+          <a:noFill/>
+          <a:ln/>
+        </p:spPr>
+        <p:txBody>
+          <a:bodyPr wrap="square" lIns="0" tIns="0" rIns="0" bIns="0" rtlCol="0" anchor="t"/>
+          <a:lstStyle/>
+          <a:p>
+            <a:pPr indent="0" marL="0">
+              <a:buNone/>
+            </a:pPr>
+            <a:r>
+              <a:rPr lang="en-US" sz="3400" b="1" dirty="0">
+                <a:solidFill>
+                  <a:schemeClr val="accent2"/>
+                </a:solidFill>
+                <a:latin typeface="Cambria" pitchFamily="34" charset="0"/>
+                <a:ea typeface="Cambria" pitchFamily="34" charset="-122"/>
+                <a:cs typeface="Cambria" pitchFamily="34" charset="-120"/>
+              </a:rPr>
+              <a:t>&lt; 1 mm2</a:t>
+            </a:r>
+            <a:endParaRPr lang="en-US" sz="3400" dirty="0"/>
+          </a:p>
+        </p:txBody>
+      </p:sp>
+      <p:sp>
+        <p:nvSpPr>
+          <p:cNvPr id="17" name="Text 15"/>
+          <p:cNvSpPr txBox="1"/>
+          <p:nvPr/>
+        </p:nvSpPr>
+        <p:spPr>
+          <a:xfrm>
+            <a:off x="4846320" y="3630168"/>
+            <a:ext cx="3657600" cy="502920"/>
+          </a:xfrm>
+          <a:prstGeom prst="rect">
+            <a:avLst/>
+          </a:prstGeom>
+          <a:noFill/>
+          <a:ln/>
+        </p:spPr>
+        <p:txBody>
+          <a:bodyPr wrap="square" lIns="0" tIns="0" rIns="0" bIns="0" rtlCol="0" anchor="t"/>
+          <a:lstStyle/>
+          <a:p>
+            <a:pPr indent="0" marL="0">
+              <a:buNone/>
+            </a:pPr>
+            <a:r>
+              <a:rPr lang="en-US" sz="1300" dirty="0">
+                <a:solidFill>
+                  <a:schemeClr val="tx1"/>
+                </a:solidFill>
+                <a:latin typeface="Calibri" pitchFamily="34" charset="0"/>
+                <a:ea typeface="Calibri" pitchFamily="34" charset="-122"/>
+                <a:cs typeface="Calibri" pitchFamily="34" charset="-120"/>
+              </a:rPr>
+              <a:t>SKY130 logic area; 18.8 mm2 with open SRAM macros</a:t>
+            </a:r>
+            <a:endParaRPr lang="en-US" sz="1300" dirty="0"/>
+          </a:p>
+        </p:txBody>
+      </p:sp>
+      <p:sp>
+        <p:nvSpPr>
+          <p:cNvPr id="18" name="Text 16"/>
+          <p:cNvSpPr txBox="1"/>
+          <p:nvPr/>
+        </p:nvSpPr>
+        <p:spPr>
+          <a:xfrm>
+            <a:off x="4846320" y="4142232"/>
+            <a:ext cx="3657600" cy="228600"/>
+          </a:xfrm>
+          <a:prstGeom prst="rect">
+            <a:avLst/>
+          </a:prstGeom>
+          <a:noFill/>
+          <a:ln/>
+        </p:spPr>
+        <p:txBody>
+          <a:bodyPr wrap="square" lIns="0" tIns="0" rIns="0" bIns="0" rtlCol="0" anchor="t"/>
+          <a:lstStyle/>
+          <a:p>
+            <a:pPr indent="0" marL="0">
+              <a:buNone/>
+            </a:pPr>
+            <a:r>
+              <a:rPr lang="en-US" sz="1100" b="1" dirty="0">
+                <a:solidFill>
+                  <a:schemeClr val="accent6"/>
+                </a:solidFill>
+                <a:latin typeface="Calibri" pitchFamily="34" charset="0"/>
+                <a:ea typeface="Calibri" pitchFamily="34" charset="-122"/>
+                <a:cs typeface="Calibri" pitchFamily="34" charset="-120"/>
+              </a:rPr>
+              <a:t>ESTIMATED</a:t>
+            </a:r>
+            <a:endParaRPr lang="en-US" sz="1100" dirty="0"/>
+          </a:p>
+        </p:txBody>
+      </p:sp>
+      <p:sp>
+        <p:nvSpPr>
+          <p:cNvPr id="19" name="Text 17"/>
+          <p:cNvSpPr txBox="1"/>
+          <p:nvPr/>
+        </p:nvSpPr>
+        <p:spPr>
+          <a:xfrm>
+            <a:off x="457200" y="4526280"/>
+            <a:ext cx="7955280" cy="411480"/>
+          </a:xfrm>
+          <a:prstGeom prst="rect">
+            <a:avLst/>
+          </a:prstGeom>
+          <a:noFill/>
+          <a:ln/>
+        </p:spPr>
+        <p:txBody>
+          <a:bodyPr wrap="square" lIns="0" tIns="0" rIns="0" bIns="0" rtlCol="0" anchor="t"/>
+          <a:lstStyle/>
+          <a:p>
+            <a:pPr indent="0" marL="0">
+              <a:buNone/>
+            </a:pPr>
+            <a:r>
+              <a:rPr lang="en-US" sz="1200" dirty="0">
+                <a:solidFill>
+                  <a:schemeClr val="accent4"/>
+                </a:solidFill>
+                <a:latin typeface="Calibri" pitchFamily="34" charset="0"/>
+                <a:ea typeface="Calibri" pitchFamily="34" charset="-122"/>
+                <a:cs typeface="Calibri" pitchFamily="34" charset="-120"/>
+              </a:rPr>
+              <a:t>Say it carefully: the 74x is per operation needed. The SKY130 layout estimate is 0.18 to 0.26 uJ per decision, still 20 to 28x above the operation count.</a:t>
+            </a:r>
+            <a:endParaRPr lang="en-US" sz="1200" dirty="0"/>
           </a:p>
         </p:txBody>
       </p:sp>

</xml_diff>

<commit_message>
Deck, script, Q&A, paper refreshed with slow table K=5 numbers
</commit_message>
<xml_diff>
--- a/docs/SPARK_Cortex_pitch.pptx
+++ b/docs/SPARK_Cortex_pitch.pptx
@@ -120,18 +120,18 @@
   <p:extLst>
     <p:ext uri="{521415D9-36F7-43E2-AB2F-B90AF26B5E84}">
       <p14:sectionLst xmlns:p14="http://schemas.microsoft.com/office/powerpoint/2010/main">
-        <p14:section name="Open" id="{5ff41065-fab5-af45-604a-59f283b2263e}">
+        <p14:section name="Open" id="{594a3ec2-8dcf-2d9d-a41f-c87cd5a4ad20}">
           <p14:sldIdLst>
             <p14:sldId id="256"/>
           </p14:sldIdLst>
         </p14:section>
-        <p14:section name="Why" id="{40e805c7-024b-2569-da3b-251581b27d51}">
+        <p14:section name="Why" id="{e54ba140-2343-0f01-39d0-2b973e2c85ba}">
           <p14:sldIdLst>
             <p14:sldId id="257"/>
             <p14:sldId id="258"/>
           </p14:sldIdLst>
         </p14:section>
-        <p14:section name="Results" id="{8897a9a4-6e0c-19a1-279b-323592d2c1b0}">
+        <p14:section name="Results" id="{ebe8fd18-f8b9-c0ef-1884-5638580e2a13}">
           <p14:sldIdLst>
             <p14:sldId id="259"/>
             <p14:sldId id="260"/>
@@ -140,19 +140,19 @@
             <p14:sldId id="263"/>
           </p14:sldIdLst>
         </p14:section>
-        <p14:section name="Build" id="{48c7cf29-5af1-513d-8bd6-2ad5fa663df5}">
+        <p14:section name="Build" id="{a4e5f2c0-5ebb-bbf3-a8a8-8cabd6aae112}">
           <p14:sldIdLst>
             <p14:sldId id="264"/>
             <p14:sldId id="265"/>
           </p14:sldIdLst>
         </p14:section>
-        <p14:section name="Honest" id="{51403f78-9ea5-70f4-4793-63572105e827}">
+        <p14:section name="Honest" id="{d377b2ad-319b-4d7f-6e8d-69bb1162fc14}">
           <p14:sldIdLst>
             <p14:sldId id="266"/>
             <p14:sldId id="267"/>
           </p14:sldIdLst>
         </p14:section>
-        <p14:section name="Next" id="{9a60aa46-ab06-1710-5722-dc4f66d86d0d}">
+        <p14:section name="Next" id="{f544e580-16a1-b918-fd7f-35ee91d6d061}">
           <p14:sldIdLst>
             <p14:sldId id="268"/>
             <p14:sldId id="269"/>
@@ -217,7 +217,7 @@
               <c:strCache>
                 <c:ptCount val="1"/>
                 <c:pt idx="0">
-                  <c:v>SPARK Cortex</c:v>
+                  <c:v>SPARK Cortex (slow-table option)</c:v>
                 </c:pt>
               </c:strCache>
             </c:strRef>
@@ -279,13 +279,13 @@
                 <c:formatCode>General</c:formatCode>
                 <c:ptCount val="3"/>
                 <c:pt idx="0">
-                  <c:v>95.8</c:v>
+                  <c:v>95.9</c:v>
                 </c:pt>
                 <c:pt idx="1">
-                  <c:v>78.3</c:v>
+                  <c:v>81.4</c:v>
                 </c:pt>
                 <c:pt idx="2">
-                  <c:v>82.9</c:v>
+                  <c:v>83.6</c:v>
                 </c:pt>
               </c:numCache>
             </c:numRef>
@@ -1678,13 +1678,13 @@
                 <c:formatCode>General</c:formatCode>
                 <c:ptCount val="3"/>
                 <c:pt idx="0">
-                  <c:v>98.3</c:v>
+                  <c:v>98.4</c:v>
                 </c:pt>
                 <c:pt idx="1">
-                  <c:v>87.9</c:v>
+                  <c:v>88.3</c:v>
                 </c:pt>
                 <c:pt idx="2">
-                  <c:v>87.2</c:v>
+                  <c:v>87.5</c:v>
                 </c:pt>
               </c:numCache>
             </c:numRef>
@@ -2511,7 +2511,7 @@
           <a:p>
             <a:r>
               <a:rPr lang="en-US" dirty="0"/>
-              <a:t>This is the slide I want you to remember. Learning everything at once, with the slow-table option, the chip is level with a small network: 98.3 against 97.8 on digits, 87.9 against 87.3 on clothing, 87.2 against 85.5 on words, simulated, five seeds. Level, not better: a small convolutional network reaches about 89 on clothing and 91 on words. In stages clothing is 78 to 80 percent. New spoken words from one to five recordings are weak. We tried many fixes and recorded the failures, such as a second sensory layer, wider sound detectors and a shared prototype pool. And nothing is measured on hardware yet.</a:t>
+              <a:t>This is the slide I want you to remember. Learning everything at once, with the slow-table option, the chip is level with a small network: 98.4 against 97.8 on digits, 88.3 against 87.3 on clothing, 87.5 against 85.5 on words, simulated, five seeds. Level, not better: a small convolutional network reaches about 89 on clothing and 91 on words. In stages clothing is 81 percent, digits 95 and words 83. New spoken words from one to five recordings are weak. We tried many fixes and recorded the failures, such as a second sensory layer, wider sound detectors and a shared prototype pool. And nothing is measured on hardware yet.</a:t>
             </a:r>
             <a:endParaRPr lang="en-US" dirty="0"/>
           </a:p>
@@ -3039,7 +3039,7 @@
           <a:p>
             <a:r>
               <a:rPr lang="en-US" dirty="0"/>
-              <a:t>Here is the core result. Learning five stages of two classes each, the chip keeps 95.8 percent on digits, 78.3 on clothing and 82.9 on spoken words, while a network that fine-tunes on each stage drops to roughly a fifth. This is simulated with the exact integer model, five seeds, and the RTL is bit-exact with it. Even one class at a time it holds 93, 79 and 71 percent in the earlier measurement.</a:t>
+              <a:t>Here is the core result. Learning five stages of two classes each, the chip with the slow-table option keeps 95.9 percent on digits, 81.4 on clothing and 83.6 on spoken words (95.8, 78.3 and 82.9 without it), while a network that fine-tunes on each stage drops to roughly a fifth. This is simulated with the exact integer model, five seeds, and the RTL is bit-exact with it. Even one class at a time it holds 93, 79 and 71 percent in the earlier measurement.</a:t>
             </a:r>
             <a:endParaRPr lang="en-US" dirty="0"/>
           </a:p>
@@ -3391,7 +3391,7 @@
           <a:p>
             <a:r>
               <a:rPr lang="en-US" dirty="0"/>
-              <a:t>We asked what actually limits the scores and tested it. A floating-point classifier trained on the chip's own code reaches 87.9 percent on clothing and 98.3 on digits, so the senses are not the limit. The chip's one-pass 5-bit readout is. A slow second table that follows the fast one fixes most of that: clothing 83.4 to 86.9, words 83 to 86, digits 97.0 to 97.6, with shifts and adds only, checked bit-exact in the RTL. A finer detector grid for images adds more, but it makes staged digits worse, so it stays an option. All simulated.</a:t>
+              <a:t>We asked what actually limits the scores and tested it. A floating-point classifier trained on the chip's own code reaches 87.9 percent on clothing and 98.3 on digits, so the senses are not the limit. The chip's one-pass 5-bit readout is. A slow second table that follows the fast one, slowly, fixes most of that: clothing 83.4 to 87.6, words 83 to 86, digits 97.0 to 97.8, and staged clothing 78.4 to 81.6, because slow consolidation damps the bias toward the newest classes. It uses shifts and adds only and is checked bit-exact in the RTL. A finer detector grid for images adds a little more all at once, but it made staged digits worse in an earlier setting, so it stays an option. All simulated.</a:t>
             </a:r>
             <a:endParaRPr lang="en-US" dirty="0"/>
           </a:p>
@@ -4782,7 +4782,7 @@
                 <a:ea typeface="Calibri" pitchFamily="34" charset="-122"/>
                 <a:cs typeface="Calibri" pitchFamily="34" charset="-120"/>
               </a:rPr>
-              <a:t>In stages clothing is 78 to 80%; digits 95%</a:t>
+              <a:t>In stages: clothing 81%, digits 95%, words 83%</a:t>
             </a:r>
             <a:endParaRPr lang="en-US" sz="1400" dirty="0"/>
           </a:p>
@@ -9176,7 +9176,7 @@
                 <a:ea typeface="Calibri" pitchFamily="34" charset="-122"/>
                 <a:cs typeface="Calibri" pitchFamily="34" charset="-120"/>
               </a:rPr>
-              <a:t>A slow second table averages the fast one: clothing 83.4 to 86.9, words 83.1 to 85.7, digits 97.0 to 97.6. Shifts and adds only; bit-exact in RTL; an ASIC option.</a:t>
+              <a:t>A slow second table averages the fast one, slowly: clothing 83.4 to 87.6, words 83.1 to 86.4, digits 97.0 to 97.8; in stages clothing 78.4 to 81.6. Shifts and adds only; bit-exact in RTL; an ASIC option.</a:t>
             </a:r>
             <a:endParaRPr lang="en-US" sz="1300" dirty="0"/>
           </a:p>
@@ -9345,7 +9345,7 @@
                 <a:ea typeface="Calibri" pitchFamily="34" charset="-122"/>
                 <a:cs typeface="Calibri" pitchFamily="34" charset="-120"/>
               </a:rPr>
-              <a:t>A finer detector grid for images: clothing 88.0, digits 98.3 all at once. It makes staged digits worse (93.2%), so it is an option.</a:t>
+              <a:t>A finer detector grid for images adds a little more all at once, but it made staged digits worse in an earlier setting, so it is an option.</a:t>
             </a:r>
             <a:endParaRPr lang="en-US" sz="1300" dirty="0"/>
           </a:p>

</xml_diff>

<commit_message>
Deck slide 4 text: 10-stage numbers measured today
</commit_message>
<xml_diff>
--- a/docs/SPARK_Cortex_pitch.pptx
+++ b/docs/SPARK_Cortex_pitch.pptx
@@ -120,18 +120,18 @@
   <p:extLst>
     <p:ext uri="{521415D9-36F7-43E2-AB2F-B90AF26B5E84}">
       <p14:sectionLst xmlns:p14="http://schemas.microsoft.com/office/powerpoint/2010/main">
-        <p14:section name="Open" id="{594a3ec2-8dcf-2d9d-a41f-c87cd5a4ad20}">
+        <p14:section name="Open" id="{d8b01e66-b0c3-46af-5749-c53bde4f0a86}">
           <p14:sldIdLst>
             <p14:sldId id="256"/>
           </p14:sldIdLst>
         </p14:section>
-        <p14:section name="Why" id="{e54ba140-2343-0f01-39d0-2b973e2c85ba}">
+        <p14:section name="Why" id="{e01091c0-15ce-5c6e-84ac-33f71de45590}">
           <p14:sldIdLst>
             <p14:sldId id="257"/>
             <p14:sldId id="258"/>
           </p14:sldIdLst>
         </p14:section>
-        <p14:section name="Results" id="{ebe8fd18-f8b9-c0ef-1884-5638580e2a13}">
+        <p14:section name="Results" id="{c0806cc5-b510-8d53-23f3-29c8e491ecf9}">
           <p14:sldIdLst>
             <p14:sldId id="259"/>
             <p14:sldId id="260"/>
@@ -140,19 +140,19 @@
             <p14:sldId id="263"/>
           </p14:sldIdLst>
         </p14:section>
-        <p14:section name="Build" id="{a4e5f2c0-5ebb-bbf3-a8a8-8cabd6aae112}">
+        <p14:section name="Build" id="{1ed1e07d-2e6d-decb-a96c-2e9776809944}">
           <p14:sldIdLst>
             <p14:sldId id="264"/>
             <p14:sldId id="265"/>
           </p14:sldIdLst>
         </p14:section>
-        <p14:section name="Honest" id="{d377b2ad-319b-4d7f-6e8d-69bb1162fc14}">
+        <p14:section name="Honest" id="{dddec663-b004-8c63-3073-87fa44dfc3ac}">
           <p14:sldIdLst>
             <p14:sldId id="266"/>
             <p14:sldId id="267"/>
           </p14:sldIdLst>
         </p14:section>
-        <p14:section name="Next" id="{f544e580-16a1-b918-fd7f-35ee91d6d061}">
+        <p14:section name="Next" id="{e8239c99-7577-7e9b-580f-34eace7072cf}">
           <p14:sldIdLst>
             <p14:sldId id="268"/>
             <p14:sldId id="269"/>
@@ -3039,7 +3039,7 @@
           <a:p>
             <a:r>
               <a:rPr lang="en-US" dirty="0"/>
-              <a:t>Here is the core result. Learning five stages of two classes each, the chip with the slow-table option keeps 95.9 percent on digits, 81.4 on clothing and 83.6 on spoken words (95.8, 78.3 and 82.9 without it), while a network that fine-tunes on each stage drops to roughly a fifth. This is simulated with the exact integer model, five seeds, and the RTL is bit-exact with it. Even one class at a time it holds 93, 79 and 71 percent in the earlier measurement.</a:t>
+              <a:t>Here is the core result. Learning five stages of two classes each, the chip with the slow-table option keeps 95.9 percent on digits, 81.4 on clothing and 83.6 on spoken words (95.8, 78.3 and 82.9 without it), while a network that fine-tunes on each stage drops to roughly a fifth. This is simulated with the exact integer model, five seeds, and the RTL is bit-exact with it. Even one class at a time, with today's design, it holds 94 percent on digits and 79 on clothing.</a:t>
             </a:r>
             <a:endParaRPr lang="en-US" dirty="0"/>
           </a:p>
@@ -7745,7 +7745,7 @@
                 <a:ea typeface="Calibri" pitchFamily="34" charset="-122"/>
                 <a:cs typeface="Calibri" pitchFamily="34" charset="-120"/>
               </a:rPr>
-              <a:t>One class at a time (10 stages): 93.0 / 78.7 / 71.2 vs a network near 10.</a:t>
+              <a:t>One class at a time (10 stages, today's design): digits 93.6, clothing 79.1 vs a network near 10.</a:t>
             </a:r>
             <a:endParaRPr lang="en-US" sz="1400" dirty="0"/>
           </a:p>

</xml_diff>